<commit_message>
Adiciona indice a apresentacao v2
- novo slide 2 com o indice (5 secoes) e numeracao das paginas atualizada
- remove o ficheiro temporario do PowerPoint (~$FrotaGest_PowerPoint_v2.pptx)

Co-Authored-By: Claude Opus 5.5 <noreply@anthropic.com>
</commit_message>
<xml_diff>
--- a/Docs/FrotaGest_PowerPoint_v2.pptx
+++ b/Docs/FrotaGest_PowerPoint_v2.pptx
@@ -9,6 +9,7 @@
   </p:notesMasterIdLst>
   <p:sldIdLst>
     <p:sldId id="256" r:id="rId2"/>
+    <p:sldId id="274" r:id="rId20"/>
     <p:sldId id="258" r:id="rId3"/>
     <p:sldId id="259" r:id="rId4"/>
     <p:sldId id="260" r:id="rId5"/>
@@ -2047,7 +2048,7 @@
                 <a:ea typeface="Aptos" pitchFamily="34" charset="-122"/>
                 <a:cs typeface="Aptos" pitchFamily="34" charset="-120"/>
               </a:rPr>
-              <a:t>10</a:t>
+              <a:t>11</a:t>
             </a:r>
             <a:endParaRPr lang="en-US" sz="900" dirty="0"/>
           </a:p>
@@ -3175,7 +3176,7 @@
                 <a:ea typeface="Aptos" pitchFamily="34" charset="-122"/>
                 <a:cs typeface="Aptos" pitchFamily="34" charset="-120"/>
               </a:rPr>
-              <a:t>11</a:t>
+              <a:t>12</a:t>
             </a:r>
             <a:endParaRPr lang="en-US" sz="900" dirty="0"/>
           </a:p>
@@ -3972,7 +3973,7 @@
                 <a:ea typeface="Aptos" pitchFamily="34" charset="-122"/>
                 <a:cs typeface="Aptos" pitchFamily="34" charset="-120"/>
               </a:rPr>
-              <a:t>12</a:t>
+              <a:t>13</a:t>
             </a:r>
             <a:endParaRPr lang="en-US" sz="900" dirty="0"/>
           </a:p>
@@ -4908,6 +4909,1257 @@
 </p:sld>
 </file>
 
+<file path=ppt/slides/slide14.xml><?xml version="1.0" encoding="utf-8"?>
+<p:sld xmlns:a="http://schemas.openxmlformats.org/drawingml/2006/main" xmlns:r="http://schemas.openxmlformats.org/officeDocument/2006/relationships" xmlns:p="http://schemas.openxmlformats.org/presentationml/2006/main">
+  <p:cSld name="Slide 5">
+    <p:bg>
+      <p:bgPr>
+        <a:solidFill>
+          <a:srgbClr val="F8FAFD"/>
+        </a:solidFill>
+        <a:effectLst/>
+      </p:bgPr>
+    </p:bg>
+    <p:spTree>
+      <p:nvGrpSpPr>
+        <p:cNvPr id="1" name=""/>
+        <p:cNvGrpSpPr/>
+        <p:nvPr/>
+      </p:nvGrpSpPr>
+      <p:grpSpPr>
+        <a:xfrm>
+          <a:off x="0" y="0"/>
+          <a:ext cx="0" cy="0"/>
+          <a:chOff x="0" y="0"/>
+          <a:chExt cx="0" cy="0"/>
+        </a:xfrm>
+      </p:grpSpPr>
+      <p:sp>
+        <p:nvSpPr>
+          <p:cNvPr id="2" name="Shape 0"/>
+          <p:cNvSpPr/>
+          <p:nvPr/>
+        </p:nvSpPr>
+        <p:spPr>
+          <a:xfrm>
+            <a:off x="0" y="0"/>
+            <a:ext cx="12191695" cy="118872"/>
+          </a:xfrm>
+          <a:prstGeom prst="rect">
+            <a:avLst/>
+          </a:prstGeom>
+          <a:solidFill>
+            <a:srgbClr val="2463EB"/>
+          </a:solidFill>
+          <a:ln w="7620">
+            <a:solidFill>
+              <a:srgbClr val="2463EB"/>
+            </a:solidFill>
+            <a:prstDash val="solid"/>
+          </a:ln>
+        </p:spPr>
+        <p:txBody>
+          <a:bodyPr/>
+          <a:lstStyle/>
+          <a:p>
+            <a:endParaRPr lang="pt-PT"/>
+          </a:p>
+        </p:txBody>
+      </p:sp>
+      <p:sp>
+        <p:nvSpPr>
+          <p:cNvPr id="3" name="Text 1"/>
+          <p:cNvSpPr/>
+          <p:nvPr/>
+        </p:nvSpPr>
+        <p:spPr>
+          <a:xfrm>
+            <a:off x="566928" y="329184"/>
+            <a:ext cx="11064240" cy="493776"/>
+          </a:xfrm>
+          <a:prstGeom prst="rect">
+            <a:avLst/>
+          </a:prstGeom>
+          <a:noFill/>
+          <a:ln/>
+        </p:spPr>
+        <p:txBody>
+          <a:bodyPr wrap="square" lIns="0" tIns="0" rIns="0" bIns="0" rtlCol="0" anchor="ctr"/>
+          <a:lstStyle/>
+          <a:p>
+            <a:pPr marL="0" indent="0">
+              <a:buNone/>
+            </a:pPr>
+            <a:r>
+              <a:rPr lang="en-US" sz="2700" b="1" dirty="0">
+                <a:solidFill>
+                  <a:srgbClr val="10243A"/>
+                </a:solidFill>
+                <a:latin typeface="Aptos" pitchFamily="34" charset="0"/>
+                <a:ea typeface="Aptos" pitchFamily="34" charset="-122"/>
+                <a:cs typeface="Aptos" pitchFamily="34" charset="-120"/>
+              </a:rPr>
+              <a:t>Índice</a:t>
+            </a:r>
+            <a:endParaRPr lang="en-US" sz="2700" dirty="0"/>
+          </a:p>
+        </p:txBody>
+      </p:sp>
+      <p:sp>
+        <p:nvSpPr>
+          <p:cNvPr id="4" name="Text 2"/>
+          <p:cNvSpPr/>
+          <p:nvPr/>
+        </p:nvSpPr>
+        <p:spPr>
+          <a:xfrm>
+            <a:off x="585216" y="868680"/>
+            <a:ext cx="10881360" cy="320040"/>
+          </a:xfrm>
+          <a:prstGeom prst="rect">
+            <a:avLst/>
+          </a:prstGeom>
+          <a:noFill/>
+          <a:ln/>
+        </p:spPr>
+        <p:txBody>
+          <a:bodyPr wrap="square" lIns="0" tIns="0" rIns="0" bIns="0" rtlCol="0" anchor="ctr"/>
+          <a:lstStyle/>
+          <a:p>
+            <a:pPr marL="0" indent="0">
+              <a:buNone/>
+            </a:pPr>
+            <a:r>
+              <a:rPr lang="en-US" sz="1150" dirty="0">
+                <a:solidFill>
+                  <a:srgbClr val="5B6A7D"/>
+                </a:solidFill>
+                <a:latin typeface="Aptos" pitchFamily="34" charset="0"/>
+                <a:ea typeface="Aptos" pitchFamily="34" charset="-122"/>
+                <a:cs typeface="Aptos" pitchFamily="34" charset="-120"/>
+              </a:rPr>
+              <a:t>O que vamos apresentar</a:t>
+            </a:r>
+            <a:endParaRPr lang="en-US" sz="1150" dirty="0"/>
+          </a:p>
+        </p:txBody>
+      </p:sp>
+      <p:sp>
+        <p:nvSpPr>
+          <p:cNvPr id="5" name="Shape 3"/>
+          <p:cNvSpPr/>
+          <p:nvPr/>
+        </p:nvSpPr>
+        <p:spPr>
+          <a:xfrm>
+            <a:off x="566928" y="6510528"/>
+            <a:ext cx="11064240" cy="10973"/>
+          </a:xfrm>
+          <a:prstGeom prst="rect">
+            <a:avLst/>
+          </a:prstGeom>
+          <a:solidFill>
+            <a:srgbClr val="DDE6F0"/>
+          </a:solidFill>
+          <a:ln w="7620">
+            <a:solidFill>
+              <a:srgbClr val="DDE6F0"/>
+            </a:solidFill>
+            <a:prstDash val="solid"/>
+          </a:ln>
+        </p:spPr>
+        <p:txBody>
+          <a:bodyPr/>
+          <a:lstStyle/>
+          <a:p>
+            <a:endParaRPr lang="pt-PT"/>
+          </a:p>
+        </p:txBody>
+      </p:sp>
+      <p:sp>
+        <p:nvSpPr>
+          <p:cNvPr id="6" name="Text 4"/>
+          <p:cNvSpPr/>
+          <p:nvPr/>
+        </p:nvSpPr>
+        <p:spPr>
+          <a:xfrm>
+            <a:off x="594360" y="6556248"/>
+            <a:ext cx="5486400" cy="173736"/>
+          </a:xfrm>
+          <a:prstGeom prst="rect">
+            <a:avLst/>
+          </a:prstGeom>
+          <a:noFill/>
+          <a:ln/>
+        </p:spPr>
+        <p:txBody>
+          <a:bodyPr wrap="square" lIns="0" tIns="0" rIns="0" bIns="0" rtlCol="0" anchor="ctr"/>
+          <a:lstStyle/>
+          <a:p>
+            <a:pPr marL="0" indent="0">
+              <a:buNone/>
+            </a:pPr>
+            <a:r>
+              <a:rPr lang="en-US" sz="800" dirty="0">
+                <a:solidFill>
+                  <a:srgbClr val="5B6A7D"/>
+                </a:solidFill>
+                <a:latin typeface="Aptos" pitchFamily="34" charset="0"/>
+                <a:ea typeface="Aptos" pitchFamily="34" charset="-122"/>
+                <a:cs typeface="Aptos" pitchFamily="34" charset="-120"/>
+              </a:rPr>
+              <a:t>FrotaGest  •  PSI 2026/2027</a:t>
+            </a:r>
+            <a:endParaRPr lang="en-US" sz="800" dirty="0"/>
+          </a:p>
+        </p:txBody>
+      </p:sp>
+      <p:sp>
+        <p:nvSpPr>
+          <p:cNvPr id="7" name="Text 5"/>
+          <p:cNvSpPr/>
+          <p:nvPr/>
+        </p:nvSpPr>
+        <p:spPr>
+          <a:xfrm>
+            <a:off x="11018520" y="6528816"/>
+            <a:ext cx="457200" cy="182880"/>
+          </a:xfrm>
+          <a:prstGeom prst="rect">
+            <a:avLst/>
+          </a:prstGeom>
+          <a:noFill/>
+          <a:ln/>
+        </p:spPr>
+        <p:txBody>
+          <a:bodyPr wrap="square" lIns="0" tIns="0" rIns="0" bIns="0" rtlCol="0" anchor="ctr"/>
+          <a:lstStyle/>
+          <a:p>
+            <a:pPr marL="0" indent="0" algn="r">
+              <a:buNone/>
+            </a:pPr>
+            <a:r>
+              <a:rPr lang="en-US" sz="900" dirty="0">
+                <a:solidFill>
+                  <a:srgbClr val="5B6A7D"/>
+                </a:solidFill>
+                <a:latin typeface="Aptos" pitchFamily="34" charset="0"/>
+                <a:ea typeface="Aptos" pitchFamily="34" charset="-122"/>
+                <a:cs typeface="Aptos" pitchFamily="34" charset="-120"/>
+              </a:rPr>
+              <a:t>02</a:t>
+            </a:r>
+            <a:endParaRPr lang="en-US" sz="900" dirty="0"/>
+          </a:p>
+        </p:txBody>
+      </p:sp>
+      <p:sp>
+        <p:nvSpPr>
+          <p:cNvPr id="8" name="Shape 6"/>
+          <p:cNvSpPr/>
+          <p:nvPr/>
+        </p:nvSpPr>
+        <p:spPr>
+          <a:xfrm>
+            <a:off x="512064" y="1920240"/>
+            <a:ext cx="2148840" cy="1993392"/>
+          </a:xfrm>
+          <a:prstGeom prst="roundRect">
+            <a:avLst>
+              <a:gd name="adj" fmla="val 6422"/>
+            </a:avLst>
+          </a:prstGeom>
+          <a:solidFill>
+            <a:srgbClr val="FFFFFF"/>
+          </a:solidFill>
+          <a:ln w="7620">
+            <a:solidFill>
+              <a:srgbClr val="DDE6F0"/>
+            </a:solidFill>
+            <a:prstDash val="solid"/>
+          </a:ln>
+        </p:spPr>
+        <p:txBody>
+          <a:bodyPr/>
+          <a:lstStyle/>
+          <a:p>
+            <a:endParaRPr lang="pt-PT"/>
+          </a:p>
+        </p:txBody>
+      </p:sp>
+      <p:sp>
+        <p:nvSpPr>
+          <p:cNvPr id="9" name="Shape 7"/>
+          <p:cNvSpPr/>
+          <p:nvPr/>
+        </p:nvSpPr>
+        <p:spPr>
+          <a:xfrm>
+            <a:off x="1225296" y="1618488"/>
+            <a:ext cx="722376" cy="722376"/>
+          </a:xfrm>
+          <a:prstGeom prst="roundRect">
+            <a:avLst>
+              <a:gd name="adj" fmla="val 45570"/>
+            </a:avLst>
+          </a:prstGeom>
+          <a:solidFill>
+            <a:srgbClr val="2463EB"/>
+          </a:solidFill>
+          <a:ln w="7620">
+            <a:solidFill>
+              <a:srgbClr val="2463EB"/>
+            </a:solidFill>
+            <a:prstDash val="solid"/>
+          </a:ln>
+        </p:spPr>
+        <p:txBody>
+          <a:bodyPr/>
+          <a:lstStyle/>
+          <a:p>
+            <a:endParaRPr lang="pt-PT"/>
+          </a:p>
+        </p:txBody>
+      </p:sp>
+      <p:sp>
+        <p:nvSpPr>
+          <p:cNvPr id="10" name="Text 8"/>
+          <p:cNvSpPr/>
+          <p:nvPr/>
+        </p:nvSpPr>
+        <p:spPr>
+          <a:xfrm>
+            <a:off x="1225296" y="1737360"/>
+            <a:ext cx="722376" cy="347472"/>
+          </a:xfrm>
+          <a:prstGeom prst="rect">
+            <a:avLst/>
+          </a:prstGeom>
+          <a:noFill/>
+          <a:ln/>
+        </p:spPr>
+        <p:txBody>
+          <a:bodyPr wrap="square" lIns="0" tIns="0" rIns="0" bIns="0" rtlCol="0" anchor="ctr"/>
+          <a:lstStyle/>
+          <a:p>
+            <a:pPr marL="0" indent="0" algn="ctr">
+              <a:buNone/>
+            </a:pPr>
+            <a:r>
+              <a:rPr lang="en-US" sz="2300" b="1" dirty="0">
+                <a:solidFill>
+                  <a:srgbClr val="FFFFFF"/>
+                </a:solidFill>
+                <a:latin typeface="Aptos" pitchFamily="34" charset="0"/>
+                <a:ea typeface="Aptos" pitchFamily="34" charset="-122"/>
+                <a:cs typeface="Aptos" pitchFamily="34" charset="-120"/>
+              </a:rPr>
+              <a:t>1</a:t>
+            </a:r>
+            <a:endParaRPr lang="en-US" sz="2300" dirty="0"/>
+          </a:p>
+        </p:txBody>
+      </p:sp>
+      <p:sp>
+        <p:nvSpPr>
+          <p:cNvPr id="11" name="Text 9"/>
+          <p:cNvSpPr/>
+          <p:nvPr/>
+        </p:nvSpPr>
+        <p:spPr>
+          <a:xfrm>
+            <a:off x="658368" y="2514600"/>
+            <a:ext cx="1865376" cy="393192"/>
+          </a:xfrm>
+          <a:prstGeom prst="rect">
+            <a:avLst/>
+          </a:prstGeom>
+          <a:noFill/>
+          <a:ln/>
+        </p:spPr>
+        <p:txBody>
+          <a:bodyPr wrap="square" lIns="0" tIns="0" rIns="0" bIns="0" rtlCol="0" anchor="ctr"/>
+          <a:lstStyle/>
+          <a:p>
+            <a:pPr marL="0" indent="0" algn="ctr">
+              <a:buNone/>
+            </a:pPr>
+            <a:r>
+              <a:rPr lang="en-US" sz="1900" b="1" dirty="0">
+                <a:solidFill>
+                  <a:srgbClr val="10243A"/>
+                </a:solidFill>
+                <a:latin typeface="Aptos" pitchFamily="34" charset="0"/>
+                <a:ea typeface="Aptos" pitchFamily="34" charset="-122"/>
+                <a:cs typeface="Aptos" pitchFamily="34" charset="-120"/>
+              </a:rPr>
+              <a:t>Solução</a:t>
+            </a:r>
+            <a:endParaRPr lang="en-US" sz="1900" dirty="0"/>
+          </a:p>
+        </p:txBody>
+      </p:sp>
+      <p:sp>
+        <p:nvSpPr>
+          <p:cNvPr id="12" name="Text 10"/>
+          <p:cNvSpPr/>
+          <p:nvPr/>
+        </p:nvSpPr>
+        <p:spPr>
+          <a:xfrm>
+            <a:off x="667512" y="3017520"/>
+            <a:ext cx="1837944" cy="475488"/>
+          </a:xfrm>
+          <a:prstGeom prst="rect">
+            <a:avLst/>
+          </a:prstGeom>
+          <a:noFill/>
+          <a:ln/>
+        </p:spPr>
+        <p:txBody>
+          <a:bodyPr wrap="square" lIns="0" tIns="0" rIns="0" bIns="0" rtlCol="0" anchor="ctr"/>
+          <a:lstStyle/>
+          <a:p>
+            <a:pPr marL="0" indent="0" algn="ctr">
+              <a:buNone/>
+            </a:pPr>
+            <a:r>
+              <a:rPr lang="en-US" sz="1300" dirty="0">
+                <a:solidFill>
+                  <a:srgbClr val="5B6A7D"/>
+                </a:solidFill>
+                <a:latin typeface="Aptos" pitchFamily="34" charset="0"/>
+                <a:ea typeface="Aptos" pitchFamily="34" charset="-122"/>
+                <a:cs typeface="Aptos" pitchFamily="34" charset="-120"/>
+              </a:rPr>
+              <a:t>Proposta e perfis de utilizador</a:t>
+            </a:r>
+            <a:endParaRPr lang="en-US" sz="1300" dirty="0"/>
+          </a:p>
+        </p:txBody>
+      </p:sp>
+      <p:sp>
+        <p:nvSpPr>
+          <p:cNvPr id="13" name="Shape 11"/>
+          <p:cNvSpPr/>
+          <p:nvPr/>
+        </p:nvSpPr>
+        <p:spPr>
+          <a:xfrm>
+            <a:off x="2852928" y="1920240"/>
+            <a:ext cx="2148840" cy="1993392"/>
+          </a:xfrm>
+          <a:prstGeom prst="roundRect">
+            <a:avLst>
+              <a:gd name="adj" fmla="val 6422"/>
+            </a:avLst>
+          </a:prstGeom>
+          <a:solidFill>
+            <a:srgbClr val="FFFFFF"/>
+          </a:solidFill>
+          <a:ln w="7620">
+            <a:solidFill>
+              <a:srgbClr val="DDE6F0"/>
+            </a:solidFill>
+            <a:prstDash val="solid"/>
+          </a:ln>
+        </p:spPr>
+        <p:txBody>
+          <a:bodyPr/>
+          <a:lstStyle/>
+          <a:p>
+            <a:endParaRPr lang="pt-PT"/>
+          </a:p>
+        </p:txBody>
+      </p:sp>
+      <p:sp>
+        <p:nvSpPr>
+          <p:cNvPr id="14" name="Shape 12"/>
+          <p:cNvSpPr/>
+          <p:nvPr/>
+        </p:nvSpPr>
+        <p:spPr>
+          <a:xfrm>
+            <a:off x="3566160" y="1618488"/>
+            <a:ext cx="722376" cy="722376"/>
+          </a:xfrm>
+          <a:prstGeom prst="roundRect">
+            <a:avLst>
+              <a:gd name="adj" fmla="val 45570"/>
+            </a:avLst>
+          </a:prstGeom>
+          <a:solidFill>
+            <a:srgbClr val="2463EB"/>
+          </a:solidFill>
+          <a:ln w="7620">
+            <a:solidFill>
+              <a:srgbClr val="2463EB"/>
+            </a:solidFill>
+            <a:prstDash val="solid"/>
+          </a:ln>
+        </p:spPr>
+        <p:txBody>
+          <a:bodyPr/>
+          <a:lstStyle/>
+          <a:p>
+            <a:endParaRPr lang="pt-PT"/>
+          </a:p>
+        </p:txBody>
+      </p:sp>
+      <p:sp>
+        <p:nvSpPr>
+          <p:cNvPr id="15" name="Text 13"/>
+          <p:cNvSpPr/>
+          <p:nvPr/>
+        </p:nvSpPr>
+        <p:spPr>
+          <a:xfrm>
+            <a:off x="3566160" y="1737360"/>
+            <a:ext cx="722376" cy="347472"/>
+          </a:xfrm>
+          <a:prstGeom prst="rect">
+            <a:avLst/>
+          </a:prstGeom>
+          <a:noFill/>
+          <a:ln/>
+        </p:spPr>
+        <p:txBody>
+          <a:bodyPr wrap="square" lIns="0" tIns="0" rIns="0" bIns="0" rtlCol="0" anchor="ctr"/>
+          <a:lstStyle/>
+          <a:p>
+            <a:pPr marL="0" indent="0" algn="ctr">
+              <a:buNone/>
+            </a:pPr>
+            <a:r>
+              <a:rPr lang="en-US" sz="2300" b="1" dirty="0">
+                <a:solidFill>
+                  <a:srgbClr val="FFFFFF"/>
+                </a:solidFill>
+                <a:latin typeface="Aptos" pitchFamily="34" charset="0"/>
+                <a:ea typeface="Aptos" pitchFamily="34" charset="-122"/>
+                <a:cs typeface="Aptos" pitchFamily="34" charset="-120"/>
+              </a:rPr>
+              <a:t>2</a:t>
+            </a:r>
+            <a:endParaRPr lang="en-US" sz="2300" dirty="0"/>
+          </a:p>
+        </p:txBody>
+      </p:sp>
+      <p:sp>
+        <p:nvSpPr>
+          <p:cNvPr id="16" name="Text 14"/>
+          <p:cNvSpPr/>
+          <p:nvPr/>
+        </p:nvSpPr>
+        <p:spPr>
+          <a:xfrm>
+            <a:off x="2999232" y="2514600"/>
+            <a:ext cx="1865376" cy="393192"/>
+          </a:xfrm>
+          <a:prstGeom prst="rect">
+            <a:avLst/>
+          </a:prstGeom>
+          <a:noFill/>
+          <a:ln/>
+        </p:spPr>
+        <p:txBody>
+          <a:bodyPr wrap="square" lIns="0" tIns="0" rIns="0" bIns="0" rtlCol="0" anchor="ctr"/>
+          <a:lstStyle/>
+          <a:p>
+            <a:pPr marL="0" indent="0" algn="ctr">
+              <a:buNone/>
+            </a:pPr>
+            <a:r>
+              <a:rPr lang="en-US" sz="1900" b="1" dirty="0">
+                <a:solidFill>
+                  <a:srgbClr val="10243A"/>
+                </a:solidFill>
+                <a:latin typeface="Aptos" pitchFamily="34" charset="0"/>
+                <a:ea typeface="Aptos" pitchFamily="34" charset="-122"/>
+                <a:cs typeface="Aptos" pitchFamily="34" charset="-120"/>
+              </a:rPr>
+              <a:t>Requisição</a:t>
+            </a:r>
+            <a:endParaRPr lang="en-US" sz="1900" dirty="0"/>
+          </a:p>
+        </p:txBody>
+      </p:sp>
+      <p:sp>
+        <p:nvSpPr>
+          <p:cNvPr id="17" name="Text 15"/>
+          <p:cNvSpPr/>
+          <p:nvPr/>
+        </p:nvSpPr>
+        <p:spPr>
+          <a:xfrm>
+            <a:off x="3008376" y="3017520"/>
+            <a:ext cx="1837944" cy="475488"/>
+          </a:xfrm>
+          <a:prstGeom prst="rect">
+            <a:avLst/>
+          </a:prstGeom>
+          <a:noFill/>
+          <a:ln/>
+        </p:spPr>
+        <p:txBody>
+          <a:bodyPr wrap="square" lIns="0" tIns="0" rIns="0" bIns="0" rtlCol="0" anchor="ctr"/>
+          <a:lstStyle/>
+          <a:p>
+            <a:pPr marL="0" indent="0" algn="ctr">
+              <a:buNone/>
+            </a:pPr>
+            <a:r>
+              <a:rPr lang="en-US" sz="1300" dirty="0">
+                <a:solidFill>
+                  <a:srgbClr val="5B6A7D"/>
+                </a:solidFill>
+                <a:latin typeface="Aptos" pitchFamily="34" charset="0"/>
+                <a:ea typeface="Aptos" pitchFamily="34" charset="-122"/>
+                <a:cs typeface="Aptos" pitchFamily="34" charset="-120"/>
+              </a:rPr>
+              <a:t>Do pedido à devolução</a:t>
+            </a:r>
+            <a:endParaRPr lang="en-US" sz="1300" dirty="0"/>
+          </a:p>
+        </p:txBody>
+      </p:sp>
+      <p:sp>
+        <p:nvSpPr>
+          <p:cNvPr id="18" name="Shape 16"/>
+          <p:cNvSpPr/>
+          <p:nvPr/>
+        </p:nvSpPr>
+        <p:spPr>
+          <a:xfrm>
+            <a:off x="5193792" y="1920240"/>
+            <a:ext cx="2148840" cy="1993392"/>
+          </a:xfrm>
+          <a:prstGeom prst="roundRect">
+            <a:avLst>
+              <a:gd name="adj" fmla="val 6422"/>
+            </a:avLst>
+          </a:prstGeom>
+          <a:solidFill>
+            <a:srgbClr val="FFFFFF"/>
+          </a:solidFill>
+          <a:ln w="7620">
+            <a:solidFill>
+              <a:srgbClr val="DDE6F0"/>
+            </a:solidFill>
+            <a:prstDash val="solid"/>
+          </a:ln>
+        </p:spPr>
+        <p:txBody>
+          <a:bodyPr/>
+          <a:lstStyle/>
+          <a:p>
+            <a:endParaRPr lang="pt-PT"/>
+          </a:p>
+        </p:txBody>
+      </p:sp>
+      <p:sp>
+        <p:nvSpPr>
+          <p:cNvPr id="19" name="Shape 17"/>
+          <p:cNvSpPr/>
+          <p:nvPr/>
+        </p:nvSpPr>
+        <p:spPr>
+          <a:xfrm>
+            <a:off x="5907024" y="1618488"/>
+            <a:ext cx="722376" cy="722376"/>
+          </a:xfrm>
+          <a:prstGeom prst="roundRect">
+            <a:avLst>
+              <a:gd name="adj" fmla="val 45570"/>
+            </a:avLst>
+          </a:prstGeom>
+          <a:solidFill>
+            <a:srgbClr val="2463EB"/>
+          </a:solidFill>
+          <a:ln w="7620">
+            <a:solidFill>
+              <a:srgbClr val="2463EB"/>
+            </a:solidFill>
+            <a:prstDash val="solid"/>
+          </a:ln>
+        </p:spPr>
+        <p:txBody>
+          <a:bodyPr/>
+          <a:lstStyle/>
+          <a:p>
+            <a:endParaRPr lang="pt-PT"/>
+          </a:p>
+        </p:txBody>
+      </p:sp>
+      <p:sp>
+        <p:nvSpPr>
+          <p:cNvPr id="20" name="Text 18"/>
+          <p:cNvSpPr/>
+          <p:nvPr/>
+        </p:nvSpPr>
+        <p:spPr>
+          <a:xfrm>
+            <a:off x="5907024" y="1737360"/>
+            <a:ext cx="722376" cy="347472"/>
+          </a:xfrm>
+          <a:prstGeom prst="rect">
+            <a:avLst/>
+          </a:prstGeom>
+          <a:noFill/>
+          <a:ln/>
+        </p:spPr>
+        <p:txBody>
+          <a:bodyPr wrap="square" lIns="0" tIns="0" rIns="0" bIns="0" rtlCol="0" anchor="ctr"/>
+          <a:lstStyle/>
+          <a:p>
+            <a:pPr marL="0" indent="0" algn="ctr">
+              <a:buNone/>
+            </a:pPr>
+            <a:r>
+              <a:rPr lang="en-US" sz="2300" b="1" dirty="0">
+                <a:solidFill>
+                  <a:srgbClr val="FFFFFF"/>
+                </a:solidFill>
+                <a:latin typeface="Aptos" pitchFamily="34" charset="0"/>
+                <a:ea typeface="Aptos" pitchFamily="34" charset="-122"/>
+                <a:cs typeface="Aptos" pitchFamily="34" charset="-120"/>
+              </a:rPr>
+              <a:t>3</a:t>
+            </a:r>
+            <a:endParaRPr lang="en-US" sz="2300" dirty="0"/>
+          </a:p>
+        </p:txBody>
+      </p:sp>
+      <p:sp>
+        <p:nvSpPr>
+          <p:cNvPr id="21" name="Text 19"/>
+          <p:cNvSpPr/>
+          <p:nvPr/>
+        </p:nvSpPr>
+        <p:spPr>
+          <a:xfrm>
+            <a:off x="5340096" y="2514600"/>
+            <a:ext cx="1865376" cy="393192"/>
+          </a:xfrm>
+          <a:prstGeom prst="rect">
+            <a:avLst/>
+          </a:prstGeom>
+          <a:noFill/>
+          <a:ln/>
+        </p:spPr>
+        <p:txBody>
+          <a:bodyPr wrap="square" lIns="0" tIns="0" rIns="0" bIns="0" rtlCol="0" anchor="ctr"/>
+          <a:lstStyle/>
+          <a:p>
+            <a:pPr marL="0" indent="0" algn="ctr">
+              <a:buNone/>
+            </a:pPr>
+            <a:r>
+              <a:rPr lang="en-US" sz="1900" b="1" dirty="0">
+                <a:solidFill>
+                  <a:srgbClr val="10243A"/>
+                </a:solidFill>
+                <a:latin typeface="Aptos" pitchFamily="34" charset="0"/>
+                <a:ea typeface="Aptos" pitchFamily="34" charset="-122"/>
+                <a:cs typeface="Aptos" pitchFamily="34" charset="-120"/>
+              </a:rPr>
+              <a:t>Plataforma Web</a:t>
+            </a:r>
+            <a:endParaRPr lang="en-US" sz="1900" dirty="0"/>
+          </a:p>
+        </p:txBody>
+      </p:sp>
+      <p:sp>
+        <p:nvSpPr>
+          <p:cNvPr id="22" name="Text 20"/>
+          <p:cNvSpPr/>
+          <p:nvPr/>
+        </p:nvSpPr>
+        <p:spPr>
+          <a:xfrm>
+            <a:off x="5349240" y="3017520"/>
+            <a:ext cx="1837944" cy="475488"/>
+          </a:xfrm>
+          <a:prstGeom prst="rect">
+            <a:avLst/>
+          </a:prstGeom>
+          <a:noFill/>
+          <a:ln/>
+        </p:spPr>
+        <p:txBody>
+          <a:bodyPr wrap="square" lIns="0" tIns="0" rIns="0" bIns="0" rtlCol="0" anchor="ctr"/>
+          <a:lstStyle/>
+          <a:p>
+            <a:pPr marL="0" indent="0" algn="ctr">
+              <a:buNone/>
+            </a:pPr>
+            <a:r>
+              <a:rPr lang="en-US" sz="1300" dirty="0">
+                <a:solidFill>
+                  <a:srgbClr val="5B6A7D"/>
+                </a:solidFill>
+                <a:latin typeface="Aptos" pitchFamily="34" charset="0"/>
+                <a:ea typeface="Aptos" pitchFamily="34" charset="-122"/>
+                <a:cs typeface="Aptos" pitchFamily="34" charset="-120"/>
+              </a:rPr>
+              <a:t>Front-office e back-office</a:t>
+            </a:r>
+            <a:endParaRPr lang="en-US" sz="1300" dirty="0"/>
+          </a:p>
+        </p:txBody>
+      </p:sp>
+      <p:sp>
+        <p:nvSpPr>
+          <p:cNvPr id="23" name="Shape 21"/>
+          <p:cNvSpPr/>
+          <p:nvPr/>
+        </p:nvSpPr>
+        <p:spPr>
+          <a:xfrm>
+            <a:off x="7534656" y="1920240"/>
+            <a:ext cx="2148840" cy="1993392"/>
+          </a:xfrm>
+          <a:prstGeom prst="roundRect">
+            <a:avLst>
+              <a:gd name="adj" fmla="val 6422"/>
+            </a:avLst>
+          </a:prstGeom>
+          <a:solidFill>
+            <a:srgbClr val="FFFFFF"/>
+          </a:solidFill>
+          <a:ln w="7620">
+            <a:solidFill>
+              <a:srgbClr val="DDE6F0"/>
+            </a:solidFill>
+            <a:prstDash val="solid"/>
+          </a:ln>
+        </p:spPr>
+        <p:txBody>
+          <a:bodyPr/>
+          <a:lstStyle/>
+          <a:p>
+            <a:endParaRPr lang="pt-PT"/>
+          </a:p>
+        </p:txBody>
+      </p:sp>
+      <p:sp>
+        <p:nvSpPr>
+          <p:cNvPr id="24" name="Shape 22"/>
+          <p:cNvSpPr/>
+          <p:nvPr/>
+        </p:nvSpPr>
+        <p:spPr>
+          <a:xfrm>
+            <a:off x="8247888" y="1618488"/>
+            <a:ext cx="722376" cy="722376"/>
+          </a:xfrm>
+          <a:prstGeom prst="roundRect">
+            <a:avLst>
+              <a:gd name="adj" fmla="val 45570"/>
+            </a:avLst>
+          </a:prstGeom>
+          <a:solidFill>
+            <a:srgbClr val="2463EB"/>
+          </a:solidFill>
+          <a:ln w="7620">
+            <a:solidFill>
+              <a:srgbClr val="2463EB"/>
+            </a:solidFill>
+            <a:prstDash val="solid"/>
+          </a:ln>
+        </p:spPr>
+        <p:txBody>
+          <a:bodyPr/>
+          <a:lstStyle/>
+          <a:p>
+            <a:endParaRPr lang="pt-PT"/>
+          </a:p>
+        </p:txBody>
+      </p:sp>
+      <p:sp>
+        <p:nvSpPr>
+          <p:cNvPr id="25" name="Text 23"/>
+          <p:cNvSpPr/>
+          <p:nvPr/>
+        </p:nvSpPr>
+        <p:spPr>
+          <a:xfrm>
+            <a:off x="8247888" y="1737360"/>
+            <a:ext cx="722376" cy="347472"/>
+          </a:xfrm>
+          <a:prstGeom prst="rect">
+            <a:avLst/>
+          </a:prstGeom>
+          <a:noFill/>
+          <a:ln/>
+        </p:spPr>
+        <p:txBody>
+          <a:bodyPr wrap="square" lIns="0" tIns="0" rIns="0" bIns="0" rtlCol="0" anchor="ctr"/>
+          <a:lstStyle/>
+          <a:p>
+            <a:pPr marL="0" indent="0" algn="ctr">
+              <a:buNone/>
+            </a:pPr>
+            <a:r>
+              <a:rPr lang="en-US" sz="2300" b="1" dirty="0">
+                <a:solidFill>
+                  <a:srgbClr val="FFFFFF"/>
+                </a:solidFill>
+                <a:latin typeface="Aptos" pitchFamily="34" charset="0"/>
+                <a:ea typeface="Aptos" pitchFamily="34" charset="-122"/>
+                <a:cs typeface="Aptos" pitchFamily="34" charset="-120"/>
+              </a:rPr>
+              <a:t>4</a:t>
+            </a:r>
+            <a:endParaRPr lang="en-US" sz="2300" dirty="0"/>
+          </a:p>
+        </p:txBody>
+      </p:sp>
+      <p:sp>
+        <p:nvSpPr>
+          <p:cNvPr id="26" name="Text 24"/>
+          <p:cNvSpPr/>
+          <p:nvPr/>
+        </p:nvSpPr>
+        <p:spPr>
+          <a:xfrm>
+            <a:off x="7680960" y="2514600"/>
+            <a:ext cx="1865376" cy="393192"/>
+          </a:xfrm>
+          <a:prstGeom prst="rect">
+            <a:avLst/>
+          </a:prstGeom>
+          <a:noFill/>
+          <a:ln/>
+        </p:spPr>
+        <p:txBody>
+          <a:bodyPr wrap="square" lIns="0" tIns="0" rIns="0" bIns="0" rtlCol="0" anchor="ctr"/>
+          <a:lstStyle/>
+          <a:p>
+            <a:pPr marL="0" indent="0" algn="ctr">
+              <a:buNone/>
+            </a:pPr>
+            <a:r>
+              <a:rPr lang="en-US" sz="1900" b="1" dirty="0">
+                <a:solidFill>
+                  <a:srgbClr val="10243A"/>
+                </a:solidFill>
+                <a:latin typeface="Aptos" pitchFamily="34" charset="0"/>
+                <a:ea typeface="Aptos" pitchFamily="34" charset="-122"/>
+                <a:cs typeface="Aptos" pitchFamily="34" charset="-120"/>
+              </a:rPr>
+              <a:t>App Android</a:t>
+            </a:r>
+            <a:endParaRPr lang="en-US" sz="1900" dirty="0"/>
+          </a:p>
+        </p:txBody>
+      </p:sp>
+      <p:sp>
+        <p:nvSpPr>
+          <p:cNvPr id="27" name="Text 25"/>
+          <p:cNvSpPr/>
+          <p:nvPr/>
+        </p:nvSpPr>
+        <p:spPr>
+          <a:xfrm>
+            <a:off x="7690104" y="3017520"/>
+            <a:ext cx="1837944" cy="475488"/>
+          </a:xfrm>
+          <a:prstGeom prst="rect">
+            <a:avLst/>
+          </a:prstGeom>
+          <a:noFill/>
+          <a:ln/>
+        </p:spPr>
+        <p:txBody>
+          <a:bodyPr wrap="square" lIns="0" tIns="0" rIns="0" bIns="0" rtlCol="0" anchor="ctr"/>
+          <a:lstStyle/>
+          <a:p>
+            <a:pPr marL="0" indent="0" algn="ctr">
+              <a:buNone/>
+            </a:pPr>
+            <a:r>
+              <a:rPr lang="en-US" sz="1300" dirty="0">
+                <a:solidFill>
+                  <a:srgbClr val="5B6A7D"/>
+                </a:solidFill>
+                <a:latin typeface="Aptos" pitchFamily="34" charset="0"/>
+                <a:ea typeface="Aptos" pitchFamily="34" charset="-122"/>
+                <a:cs typeface="Aptos" pitchFamily="34" charset="-120"/>
+              </a:rPr>
+              <a:t>Pedidos, viatura e configuração</a:t>
+            </a:r>
+            <a:endParaRPr lang="en-US" sz="1300" dirty="0"/>
+          </a:p>
+        </p:txBody>
+      </p:sp>
+      <p:sp>
+        <p:nvSpPr>
+          <p:cNvPr id="28" name="Shape 26"/>
+          <p:cNvSpPr/>
+          <p:nvPr/>
+        </p:nvSpPr>
+        <p:spPr>
+          <a:xfrm>
+            <a:off x="9875520" y="1920240"/>
+            <a:ext cx="2148840" cy="1993392"/>
+          </a:xfrm>
+          <a:prstGeom prst="roundRect">
+            <a:avLst>
+              <a:gd name="adj" fmla="val 6422"/>
+            </a:avLst>
+          </a:prstGeom>
+          <a:solidFill>
+            <a:srgbClr val="FFFFFF"/>
+          </a:solidFill>
+          <a:ln w="7620">
+            <a:solidFill>
+              <a:srgbClr val="DDE6F0"/>
+            </a:solidFill>
+            <a:prstDash val="solid"/>
+          </a:ln>
+        </p:spPr>
+        <p:txBody>
+          <a:bodyPr/>
+          <a:lstStyle/>
+          <a:p>
+            <a:endParaRPr lang="pt-PT"/>
+          </a:p>
+        </p:txBody>
+      </p:sp>
+      <p:sp>
+        <p:nvSpPr>
+          <p:cNvPr id="29" name="Shape 27"/>
+          <p:cNvSpPr/>
+          <p:nvPr/>
+        </p:nvSpPr>
+        <p:spPr>
+          <a:xfrm>
+            <a:off x="10588752" y="1618488"/>
+            <a:ext cx="722376" cy="722376"/>
+          </a:xfrm>
+          <a:prstGeom prst="roundRect">
+            <a:avLst>
+              <a:gd name="adj" fmla="val 45570"/>
+            </a:avLst>
+          </a:prstGeom>
+          <a:solidFill>
+            <a:srgbClr val="11A89B"/>
+          </a:solidFill>
+          <a:ln w="7620">
+            <a:solidFill>
+              <a:srgbClr val="11A89B"/>
+            </a:solidFill>
+            <a:prstDash val="solid"/>
+          </a:ln>
+        </p:spPr>
+        <p:txBody>
+          <a:bodyPr/>
+          <a:lstStyle/>
+          <a:p>
+            <a:endParaRPr lang="pt-PT"/>
+          </a:p>
+        </p:txBody>
+      </p:sp>
+      <p:sp>
+        <p:nvSpPr>
+          <p:cNvPr id="30" name="Text 28"/>
+          <p:cNvSpPr/>
+          <p:nvPr/>
+        </p:nvSpPr>
+        <p:spPr>
+          <a:xfrm>
+            <a:off x="10588752" y="1737360"/>
+            <a:ext cx="722376" cy="347472"/>
+          </a:xfrm>
+          <a:prstGeom prst="rect">
+            <a:avLst/>
+          </a:prstGeom>
+          <a:noFill/>
+          <a:ln/>
+        </p:spPr>
+        <p:txBody>
+          <a:bodyPr wrap="square" lIns="0" tIns="0" rIns="0" bIns="0" rtlCol="0" anchor="ctr"/>
+          <a:lstStyle/>
+          <a:p>
+            <a:pPr marL="0" indent="0" algn="ctr">
+              <a:buNone/>
+            </a:pPr>
+            <a:r>
+              <a:rPr lang="en-US" sz="2300" b="1" dirty="0">
+                <a:solidFill>
+                  <a:srgbClr val="FFFFFF"/>
+                </a:solidFill>
+                <a:latin typeface="Aptos" pitchFamily="34" charset="0"/>
+                <a:ea typeface="Aptos" pitchFamily="34" charset="-122"/>
+                <a:cs typeface="Aptos" pitchFamily="34" charset="-120"/>
+              </a:rPr>
+              <a:t>5</a:t>
+            </a:r>
+            <a:endParaRPr lang="en-US" sz="2300" dirty="0"/>
+          </a:p>
+        </p:txBody>
+      </p:sp>
+      <p:sp>
+        <p:nvSpPr>
+          <p:cNvPr id="31" name="Text 29"/>
+          <p:cNvSpPr/>
+          <p:nvPr/>
+        </p:nvSpPr>
+        <p:spPr>
+          <a:xfrm>
+            <a:off x="10021824" y="2514600"/>
+            <a:ext cx="1865376" cy="393192"/>
+          </a:xfrm>
+          <a:prstGeom prst="rect">
+            <a:avLst/>
+          </a:prstGeom>
+          <a:noFill/>
+          <a:ln/>
+        </p:spPr>
+        <p:txBody>
+          <a:bodyPr wrap="square" lIns="0" tIns="0" rIns="0" bIns="0" rtlCol="0" anchor="ctr"/>
+          <a:lstStyle/>
+          <a:p>
+            <a:pPr marL="0" indent="0" algn="ctr">
+              <a:buNone/>
+            </a:pPr>
+            <a:r>
+              <a:rPr lang="en-US" sz="1900" b="1" dirty="0">
+                <a:solidFill>
+                  <a:srgbClr val="10243A"/>
+                </a:solidFill>
+                <a:latin typeface="Aptos" pitchFamily="34" charset="0"/>
+                <a:ea typeface="Aptos" pitchFamily="34" charset="-122"/>
+                <a:cs typeface="Aptos" pitchFamily="34" charset="-120"/>
+              </a:rPr>
+              <a:t>Arquitetura</a:t>
+            </a:r>
+            <a:endParaRPr lang="en-US" sz="1900" dirty="0"/>
+          </a:p>
+        </p:txBody>
+      </p:sp>
+      <p:sp>
+        <p:nvSpPr>
+          <p:cNvPr id="32" name="Text 30"/>
+          <p:cNvSpPr/>
+          <p:nvPr/>
+        </p:nvSpPr>
+        <p:spPr>
+          <a:xfrm>
+            <a:off x="10030968" y="3017520"/>
+            <a:ext cx="1837944" cy="475488"/>
+          </a:xfrm>
+          <a:prstGeom prst="rect">
+            <a:avLst/>
+          </a:prstGeom>
+          <a:noFill/>
+          <a:ln/>
+        </p:spPr>
+        <p:txBody>
+          <a:bodyPr wrap="square" lIns="0" tIns="0" rIns="0" bIns="0" rtlCol="0" anchor="ctr"/>
+          <a:lstStyle/>
+          <a:p>
+            <a:pPr marL="0" indent="0" algn="ctr">
+              <a:buNone/>
+            </a:pPr>
+            <a:r>
+              <a:rPr lang="en-US" sz="1300" dirty="0">
+                <a:solidFill>
+                  <a:srgbClr val="5B6A7D"/>
+                </a:solidFill>
+                <a:latin typeface="Aptos" pitchFamily="34" charset="0"/>
+                <a:ea typeface="Aptos" pitchFamily="34" charset="-122"/>
+                <a:cs typeface="Aptos" pitchFamily="34" charset="-120"/>
+              </a:rPr>
+              <a:t>Funcionalidades, arquitetura e planeamento</a:t>
+            </a:r>
+            <a:endParaRPr lang="en-US" sz="1300" dirty="0"/>
+          </a:p>
+        </p:txBody>
+      </p:sp>
+      <p:sp>
+        <p:nvSpPr>
+          <p:cNvPr id="33" name="Shape 31"/>
+          <p:cNvSpPr/>
+          <p:nvPr/>
+        </p:nvSpPr>
+        <p:spPr>
+          <a:xfrm>
+            <a:off x="978408" y="4681728"/>
+            <a:ext cx="10332720" cy="777240"/>
+          </a:xfrm>
+          <a:prstGeom prst="roundRect">
+            <a:avLst>
+              <a:gd name="adj" fmla="val 14118"/>
+            </a:avLst>
+          </a:prstGeom>
+          <a:solidFill>
+            <a:srgbClr val="EFF5FF"/>
+          </a:solidFill>
+          <a:ln w="7620">
+            <a:solidFill>
+              <a:srgbClr val="EFF5FF"/>
+            </a:solidFill>
+            <a:prstDash val="solid"/>
+          </a:ln>
+        </p:spPr>
+        <p:txBody>
+          <a:bodyPr/>
+          <a:lstStyle/>
+          <a:p>
+            <a:endParaRPr lang="pt-PT"/>
+          </a:p>
+        </p:txBody>
+      </p:sp>
+      <p:sp>
+        <p:nvSpPr>
+          <p:cNvPr id="34" name="Text 32"/>
+          <p:cNvSpPr/>
+          <p:nvPr/>
+        </p:nvSpPr>
+        <p:spPr>
+          <a:xfrm>
+            <a:off x="1133856" y="4901184"/>
+            <a:ext cx="10012680" cy="329184"/>
+          </a:xfrm>
+          <a:prstGeom prst="rect">
+            <a:avLst/>
+          </a:prstGeom>
+          <a:noFill/>
+          <a:ln/>
+        </p:spPr>
+        <p:txBody>
+          <a:bodyPr wrap="square" lIns="0" tIns="0" rIns="0" bIns="0" rtlCol="0" anchor="ctr"/>
+          <a:lstStyle/>
+          <a:p>
+            <a:pPr marL="0" indent="0" algn="ctr">
+              <a:buNone/>
+            </a:pPr>
+            <a:r>
+              <a:rPr lang="en-US" sz="1700" b="1" dirty="0">
+                <a:solidFill>
+                  <a:srgbClr val="2463EB"/>
+                </a:solidFill>
+                <a:latin typeface="Aptos" pitchFamily="34" charset="0"/>
+                <a:ea typeface="Aptos" pitchFamily="34" charset="-122"/>
+                <a:cs typeface="Aptos" pitchFamily="34" charset="-120"/>
+              </a:rPr>
+              <a:t>Duração: 5 minutos   •   Vitor Leonardo, Valter Beca e Gustavo Biazini</a:t>
+            </a:r>
+            <a:endParaRPr lang="en-US" sz="1700" dirty="0"/>
+          </a:p>
+        </p:txBody>
+      </p:sp>
+    </p:spTree>
+  </p:cSld>
+  <p:clrMapOvr>
+    <a:masterClrMapping/>
+  </p:clrMapOvr>
+</p:sld>
+</file>
+
 <file path=ppt/slides/slide2.xml><?xml version="1.0" encoding="utf-8"?>
 <p:sld xmlns:a="http://schemas.openxmlformats.org/drawingml/2006/main" xmlns:r="http://schemas.openxmlformats.org/officeDocument/2006/relationships" xmlns:p="http://schemas.openxmlformats.org/presentationml/2006/main">
   <p:cSld name="Slide 3">
@@ -5147,7 +6399,7 @@
                 <a:ea typeface="Aptos" pitchFamily="34" charset="-122"/>
                 <a:cs typeface="Aptos" pitchFamily="34" charset="-120"/>
               </a:rPr>
-              <a:t>02</a:t>
+              <a:t>03</a:t>
             </a:r>
             <a:endParaRPr lang="en-US" sz="900" dirty="0"/>
           </a:p>
@@ -5856,7 +7108,7 @@
                 <a:ea typeface="Aptos" pitchFamily="34" charset="-122"/>
                 <a:cs typeface="Aptos" pitchFamily="34" charset="-120"/>
               </a:rPr>
-              <a:t>03</a:t>
+              <a:t>04</a:t>
             </a:r>
             <a:endParaRPr lang="en-US" sz="900" dirty="0"/>
           </a:p>
@@ -6685,7 +7937,7 @@
                 <a:ea typeface="Aptos" pitchFamily="34" charset="-122"/>
                 <a:cs typeface="Aptos" pitchFamily="34" charset="-120"/>
               </a:rPr>
-              <a:t>04</a:t>
+              <a:t>05</a:t>
             </a:r>
             <a:endParaRPr lang="en-US" sz="900" dirty="0"/>
           </a:p>
@@ -7936,7 +9188,7 @@
                 <a:ea typeface="Aptos" pitchFamily="34" charset="-122"/>
                 <a:cs typeface="Aptos" pitchFamily="34" charset="-120"/>
               </a:rPr>
-              <a:t>05</a:t>
+              <a:t>06</a:t>
             </a:r>
             <a:endParaRPr lang="en-US" sz="900" dirty="0"/>
           </a:p>
@@ -8383,7 +9635,7 @@
                 <a:ea typeface="Aptos" pitchFamily="34" charset="-122"/>
                 <a:cs typeface="Aptos" pitchFamily="34" charset="-120"/>
               </a:rPr>
-              <a:t>06</a:t>
+              <a:t>07</a:t>
             </a:r>
             <a:endParaRPr lang="en-US" sz="900" dirty="0"/>
           </a:p>
@@ -8830,7 +10082,7 @@
                 <a:ea typeface="Aptos" pitchFamily="34" charset="-122"/>
                 <a:cs typeface="Aptos" pitchFamily="34" charset="-120"/>
               </a:rPr>
-              <a:t>07</a:t>
+              <a:t>08</a:t>
             </a:r>
             <a:endParaRPr lang="en-US" sz="900" dirty="0"/>
           </a:p>
@@ -9374,7 +10626,7 @@
                 <a:ea typeface="Aptos" pitchFamily="34" charset="-122"/>
                 <a:cs typeface="Aptos" pitchFamily="34" charset="-120"/>
               </a:rPr>
-              <a:t>08</a:t>
+              <a:t>09</a:t>
             </a:r>
             <a:endParaRPr lang="en-US" sz="900" dirty="0"/>
           </a:p>
@@ -9918,7 +11170,7 @@
                 <a:ea typeface="Aptos" pitchFamily="34" charset="-122"/>
                 <a:cs typeface="Aptos" pitchFamily="34" charset="-120"/>
               </a:rPr>
-              <a:t>09</a:t>
+              <a:t>10</a:t>
             </a:r>
             <a:endParaRPr lang="en-US" sz="900" dirty="0"/>
           </a:p>

</xml_diff>

<commit_message>
Arquitetura da apresentacao v2 segundo o enunciado
- slide 12 refeito com base na Figura 1 do enunciado de PSI: app Android
  ligada a API por HTTP, servidor de producao (ESTG) com os grupos SIS
  (API REST e messaging) e PLSI (front-office e back-office), BD unica
- messaging publish/subscribe: API e back-office publicam, app subscreve
- remove o ficheiro temporario do PowerPoint (~$FrotaGest_PowerPoint_v2.pptx)

Co-Authored-By: Claude Opus 5.5 <noreply@anthropic.com>
</commit_message>
<xml_diff>
--- a/Docs/FrotaGest_PowerPoint_v2.pptx
+++ b/Docs/FrotaGest_PowerPoint_v2.pptx
@@ -3610,7 +3610,7 @@
                 <a:ea typeface="Aptos" pitchFamily="34" charset="-122"/>
                 <a:cs typeface="Aptos" pitchFamily="34" charset="-120"/>
               </a:rPr>
-              <a:t>Três componentes ligados a uma base de dados única</a:t>
+              <a:t>Arquitetura do enunciado: app móvel, API, aplicação web e base de dados única</a:t>
             </a:r>
             <a:endParaRPr lang="en-US" sz="1150" dirty="0"/>
           </a:p>
@@ -3728,14 +3728,109 @@
       </p:sp>
       <p:sp>
         <p:nvSpPr>
-          <p:cNvPr id="8" name="Shape 6"/>
-          <p:cNvSpPr/>
-          <p:nvPr/>
-        </p:nvSpPr>
-        <p:spPr>
-          <a:xfrm>
-            <a:off x="502920" y="1664208"/>
-            <a:ext cx="3593592" cy="1353312"/>
+          <p:cNvPr id="101" name="Shape 101"/>
+          <p:cNvSpPr/>
+          <p:nvPr/>
+        </p:nvSpPr>
+        <p:spPr>
+          <a:xfrm>
+            <a:off x="3200400" y="1417320"/>
+            <a:ext cx="5577840" cy="4846320"/>
+          </a:xfrm>
+          <a:prstGeom prst="roundRect">
+            <a:avLst>
+              <a:gd name="adj" fmla="val 3500"/>
+            </a:avLst>
+          </a:prstGeom>
+          <a:solidFill>
+            <a:srgbClr val="EAF1FD"/>
+          </a:solidFill>
+          <a:ln w="7620">
+            <a:solidFill>
+              <a:srgbClr val="B8CDF2"/>
+            </a:solidFill>
+            <a:prstDash val="solid"/>
+          </a:ln>
+        </p:spPr>
+      </p:sp>
+      <p:sp>
+        <p:nvSpPr>
+          <p:cNvPr id="102" name="Text 102"/>
+          <p:cNvSpPr txBox="1"/>
+          <p:nvPr/>
+        </p:nvSpPr>
+        <p:spPr>
+          <a:xfrm>
+            <a:off x="3383280" y="1537320"/>
+            <a:ext cx="5212080" cy="300000"/>
+          </a:xfrm>
+          <a:prstGeom prst="rect">
+            <a:avLst/>
+          </a:prstGeom>
+          <a:noFill/>
+          <a:ln>
+            <a:noFill/>
+          </a:ln>
+        </p:spPr>
+        <p:txBody>
+          <a:bodyPr wrap="square" lIns="0" tIns="0" rIns="0" bIns="0" rtlCol="0" anchor="t"/>
+          <a:lstStyle/>
+          <a:p>
+            <a:pPr algn="l" marL="0" indent="0">
+              <a:spcAft>
+                <a:spcPts val="0"/>
+              </a:spcAft>
+              <a:buNone/>
+            </a:pPr>
+            <a:r>
+              <a:rPr lang="pt-PT" sz="1300" b="1" dirty="0">
+                <a:solidFill>
+                  <a:srgbClr val="10243A"/>
+                </a:solidFill>
+                <a:latin typeface="Aptos" pitchFamily="34" charset="0"/>
+                <a:ea typeface="Aptos" pitchFamily="34" charset="-122"/>
+                <a:cs typeface="Aptos" pitchFamily="34" charset="-120"/>
+              </a:rPr>
+              <a:t>Servidor de produção (ESTG)</a:t>
+            </a:r>
+          </a:p>
+        </p:txBody>
+      </p:sp>
+      <p:sp>
+        <p:nvSpPr>
+          <p:cNvPr id="103" name="Shape 103"/>
+          <p:cNvSpPr/>
+          <p:nvPr/>
+        </p:nvSpPr>
+        <p:spPr>
+          <a:xfrm>
+            <a:off x="3383280" y="1874520"/>
+            <a:ext cx="2468880" cy="3840480"/>
+          </a:xfrm>
+          <a:prstGeom prst="roundRect">
+            <a:avLst>
+              <a:gd name="adj" fmla="val 5000"/>
+            </a:avLst>
+          </a:prstGeom>
+          <a:noFill/>
+          <a:ln w="12700">
+            <a:solidFill>
+              <a:srgbClr val="5B6A7D"/>
+            </a:solidFill>
+            <a:prstDash val="dash"/>
+          </a:ln>
+        </p:spPr>
+      </p:sp>
+      <p:sp>
+        <p:nvSpPr>
+          <p:cNvPr id="104" name="Shape 104"/>
+          <p:cNvSpPr/>
+          <p:nvPr/>
+        </p:nvSpPr>
+        <p:spPr>
+          <a:xfrm>
+            <a:off x="3520440" y="2103120"/>
+            <a:ext cx="2194560" cy="1188720"/>
           </a:xfrm>
           <a:prstGeom prst="roundRect">
             <a:avLst>
@@ -3743,49 +3838,44 @@
             </a:avLst>
           </a:prstGeom>
           <a:solidFill>
-            <a:srgbClr val="10243A"/>
-          </a:solidFill>
-          <a:ln w="7620">
-            <a:solidFill>
-              <a:srgbClr val="10243A"/>
-            </a:solidFill>
-            <a:prstDash val="solid"/>
+            <a:srgbClr val="2463EB"/>
+          </a:solidFill>
+          <a:ln>
+            <a:noFill/>
           </a:ln>
         </p:spPr>
-        <p:txBody>
-          <a:bodyPr/>
-          <a:lstStyle/>
-          <a:p>
-            <a:endParaRPr lang="pt-PT"/>
-          </a:p>
-        </p:txBody>
-      </p:sp>
-      <p:sp>
-        <p:nvSpPr>
-          <p:cNvPr id="9" name="Text 7"/>
-          <p:cNvSpPr/>
-          <p:nvPr/>
-        </p:nvSpPr>
-        <p:spPr>
-          <a:xfrm>
-            <a:off x="667512" y="1929384"/>
-            <a:ext cx="3264408" cy="365760"/>
-          </a:xfrm>
-          <a:prstGeom prst="rect">
-            <a:avLst/>
-          </a:prstGeom>
-          <a:noFill/>
-          <a:ln/>
-        </p:spPr>
-        <p:txBody>
-          <a:bodyPr wrap="square" lIns="0" tIns="0" rIns="0" bIns="0" rtlCol="0" anchor="ctr"/>
-          <a:lstStyle/>
-          <a:p>
-            <a:pPr marL="0" indent="0" algn="ctr">
-              <a:buNone/>
-            </a:pPr>
-            <a:r>
-              <a:rPr lang="en-US" sz="1900" b="1" dirty="0">
+      </p:sp>
+      <p:sp>
+        <p:nvSpPr>
+          <p:cNvPr id="105" name="Text 105"/>
+          <p:cNvSpPr txBox="1"/>
+          <p:nvPr/>
+        </p:nvSpPr>
+        <p:spPr>
+          <a:xfrm>
+            <a:off x="3610440" y="2273120"/>
+            <a:ext cx="2014560" cy="848720"/>
+          </a:xfrm>
+          <a:prstGeom prst="rect">
+            <a:avLst/>
+          </a:prstGeom>
+          <a:noFill/>
+          <a:ln>
+            <a:noFill/>
+          </a:ln>
+        </p:spPr>
+        <p:txBody>
+          <a:bodyPr wrap="square" lIns="0" tIns="0" rIns="0" bIns="0" rtlCol="0" anchor="ctr"/>
+          <a:lstStyle/>
+          <a:p>
+            <a:pPr algn="ctr" marL="0" indent="0">
+              <a:spcAft>
+                <a:spcPts val="300"/>
+              </a:spcAft>
+              <a:buNone/>
+            </a:pPr>
+            <a:r>
+              <a:rPr lang="pt-PT" sz="1700" b="1" dirty="0">
                 <a:solidFill>
                   <a:srgbClr val="FFFFFF"/>
                 </a:solidFill>
@@ -3793,61 +3883,40 @@
                 <a:ea typeface="Aptos" pitchFamily="34" charset="-122"/>
                 <a:cs typeface="Aptos" pitchFamily="34" charset="-120"/>
               </a:rPr>
-              <a:t>Web — Yii2 / PHP</a:t>
-            </a:r>
-            <a:endParaRPr lang="en-US" sz="1900" dirty="0"/>
-          </a:p>
-        </p:txBody>
-      </p:sp>
-      <p:sp>
-        <p:nvSpPr>
-          <p:cNvPr id="10" name="Text 8"/>
-          <p:cNvSpPr/>
-          <p:nvPr/>
-        </p:nvSpPr>
-        <p:spPr>
-          <a:xfrm>
-            <a:off x="667512" y="2404872"/>
-            <a:ext cx="3264408" cy="292608"/>
-          </a:xfrm>
-          <a:prstGeom prst="rect">
-            <a:avLst/>
-          </a:prstGeom>
-          <a:noFill/>
-          <a:ln/>
-        </p:spPr>
-        <p:txBody>
-          <a:bodyPr wrap="square" lIns="0" tIns="0" rIns="0" bIns="0" rtlCol="0" anchor="ctr"/>
-          <a:lstStyle/>
-          <a:p>
-            <a:pPr marL="0" indent="0" algn="ctr">
-              <a:buNone/>
-            </a:pPr>
-            <a:r>
-              <a:rPr lang="en-US" sz="1200" dirty="0">
-                <a:solidFill>
-                  <a:srgbClr val="D9E8FA"/>
-                </a:solidFill>
-                <a:latin typeface="Aptos" pitchFamily="34" charset="0"/>
-                <a:ea typeface="Aptos" pitchFamily="34" charset="-122"/>
-                <a:cs typeface="Aptos" pitchFamily="34" charset="-120"/>
-              </a:rPr>
-              <a:t>Front-office + back-office</a:t>
-            </a:r>
-            <a:endParaRPr lang="en-US" sz="1200" dirty="0"/>
-          </a:p>
-        </p:txBody>
-      </p:sp>
-      <p:sp>
-        <p:nvSpPr>
-          <p:cNvPr id="11" name="Shape 9"/>
-          <p:cNvSpPr/>
-          <p:nvPr/>
-        </p:nvSpPr>
-        <p:spPr>
-          <a:xfrm>
-            <a:off x="4507992" y="1664208"/>
-            <a:ext cx="3593592" cy="1353312"/>
+              <a:t>API REST</a:t>
+            </a:r>
+          </a:p>
+          <a:p>
+            <a:pPr algn="ctr" marL="0" indent="0">
+              <a:spcAft>
+                <a:spcPts val="0"/>
+              </a:spcAft>
+              <a:buNone/>
+            </a:pPr>
+            <a:r>
+              <a:rPr lang="pt-PT" sz="1100" dirty="0">
+                <a:solidFill>
+                  <a:srgbClr val="DCE6F5"/>
+                </a:solidFill>
+                <a:latin typeface="Aptos" pitchFamily="34" charset="0"/>
+                <a:ea typeface="Aptos" pitchFamily="34" charset="-122"/>
+                <a:cs typeface="Aptos" pitchFamily="34" charset="-120"/>
+              </a:rPr>
+              <a:t>CRUD e master/detail</a:t>
+            </a:r>
+          </a:p>
+        </p:txBody>
+      </p:sp>
+      <p:sp>
+        <p:nvSpPr>
+          <p:cNvPr id="106" name="Shape 106"/>
+          <p:cNvSpPr/>
+          <p:nvPr/>
+        </p:nvSpPr>
+        <p:spPr>
+          <a:xfrm>
+            <a:off x="3520440" y="3794760"/>
+            <a:ext cx="2194560" cy="1188720"/>
           </a:xfrm>
           <a:prstGeom prst="roundRect">
             <a:avLst>
@@ -3855,7 +3924,7 @@
             </a:avLst>
           </a:prstGeom>
           <a:solidFill>
-            <a:srgbClr val="2463EB"/>
+            <a:srgbClr val="FFFFFF"/>
           </a:solidFill>
           <a:ln w="7620">
             <a:solidFill>
@@ -3864,102 +3933,147 @@
             <a:prstDash val="solid"/>
           </a:ln>
         </p:spPr>
-        <p:txBody>
-          <a:bodyPr/>
-          <a:lstStyle/>
-          <a:p>
-            <a:endParaRPr lang="pt-PT"/>
-          </a:p>
-        </p:txBody>
-      </p:sp>
-      <p:sp>
-        <p:nvSpPr>
-          <p:cNvPr id="12" name="Text 10"/>
-          <p:cNvSpPr/>
-          <p:nvPr/>
-        </p:nvSpPr>
-        <p:spPr>
-          <a:xfrm>
-            <a:off x="4672584" y="1929384"/>
-            <a:ext cx="3264408" cy="365760"/>
-          </a:xfrm>
-          <a:prstGeom prst="rect">
-            <a:avLst/>
-          </a:prstGeom>
-          <a:noFill/>
-          <a:ln/>
-        </p:spPr>
-        <p:txBody>
-          <a:bodyPr wrap="square" lIns="0" tIns="0" rIns="0" bIns="0" rtlCol="0" anchor="ctr"/>
-          <a:lstStyle/>
-          <a:p>
-            <a:pPr marL="0" indent="0" algn="ctr">
-              <a:buNone/>
-            </a:pPr>
-            <a:r>
-              <a:rPr lang="en-US" sz="1900" b="1" dirty="0">
-                <a:solidFill>
-                  <a:srgbClr val="FFFFFF"/>
-                </a:solidFill>
-                <a:latin typeface="Aptos" pitchFamily="34" charset="0"/>
-                <a:ea typeface="Aptos" pitchFamily="34" charset="-122"/>
-                <a:cs typeface="Aptos" pitchFamily="34" charset="-120"/>
-              </a:rPr>
-              <a:t>API REST</a:t>
-            </a:r>
-            <a:endParaRPr lang="en-US" sz="1900" dirty="0"/>
-          </a:p>
-        </p:txBody>
-      </p:sp>
-      <p:sp>
-        <p:nvSpPr>
-          <p:cNvPr id="13" name="Text 11"/>
-          <p:cNvSpPr/>
-          <p:nvPr/>
-        </p:nvSpPr>
-        <p:spPr>
-          <a:xfrm>
-            <a:off x="4672584" y="2404872"/>
-            <a:ext cx="3264408" cy="292608"/>
-          </a:xfrm>
-          <a:prstGeom prst="rect">
-            <a:avLst/>
-          </a:prstGeom>
-          <a:noFill/>
-          <a:ln/>
-        </p:spPr>
-        <p:txBody>
-          <a:bodyPr wrap="square" lIns="0" tIns="0" rIns="0" bIns="0" rtlCol="0" anchor="ctr"/>
-          <a:lstStyle/>
-          <a:p>
-            <a:pPr marL="0" indent="0" algn="ctr">
-              <a:buNone/>
-            </a:pPr>
-            <a:r>
-              <a:rPr lang="en-US" sz="1200" dirty="0">
-                <a:solidFill>
-                  <a:srgbClr val="D9E8FA"/>
-                </a:solidFill>
-                <a:latin typeface="Aptos" pitchFamily="34" charset="0"/>
-                <a:ea typeface="Aptos" pitchFamily="34" charset="-122"/>
-                <a:cs typeface="Aptos" pitchFamily="34" charset="-120"/>
-              </a:rPr>
-              <a:t>CRUD e master/detail para a app</a:t>
-            </a:r>
-            <a:endParaRPr lang="en-US" sz="1200" dirty="0"/>
-          </a:p>
-        </p:txBody>
-      </p:sp>
-      <p:sp>
-        <p:nvSpPr>
-          <p:cNvPr id="14" name="Shape 12"/>
-          <p:cNvSpPr/>
-          <p:nvPr/>
-        </p:nvSpPr>
-        <p:spPr>
-          <a:xfrm>
-            <a:off x="8513064" y="1664208"/>
-            <a:ext cx="3593592" cy="1353312"/>
+      </p:sp>
+      <p:sp>
+        <p:nvSpPr>
+          <p:cNvPr id="107" name="Text 107"/>
+          <p:cNvSpPr txBox="1"/>
+          <p:nvPr/>
+        </p:nvSpPr>
+        <p:spPr>
+          <a:xfrm>
+            <a:off x="3610440" y="3964760"/>
+            <a:ext cx="2014560" cy="848720"/>
+          </a:xfrm>
+          <a:prstGeom prst="rect">
+            <a:avLst/>
+          </a:prstGeom>
+          <a:noFill/>
+          <a:ln>
+            <a:noFill/>
+          </a:ln>
+        </p:spPr>
+        <p:txBody>
+          <a:bodyPr wrap="square" lIns="0" tIns="0" rIns="0" bIns="0" rtlCol="0" anchor="ctr"/>
+          <a:lstStyle/>
+          <a:p>
+            <a:pPr algn="ctr" marL="0" indent="0">
+              <a:spcAft>
+                <a:spcPts val="300"/>
+              </a:spcAft>
+              <a:buNone/>
+            </a:pPr>
+            <a:r>
+              <a:rPr lang="pt-PT" sz="1700" b="1" dirty="0">
+                <a:solidFill>
+                  <a:srgbClr val="10243A"/>
+                </a:solidFill>
+                <a:latin typeface="Aptos" pitchFamily="34" charset="0"/>
+                <a:ea typeface="Aptos" pitchFamily="34" charset="-122"/>
+                <a:cs typeface="Aptos" pitchFamily="34" charset="-120"/>
+              </a:rPr>
+              <a:t>Messaging</a:t>
+            </a:r>
+          </a:p>
+          <a:p>
+            <a:pPr algn="ctr" marL="0" indent="0">
+              <a:spcAft>
+                <a:spcPts val="0"/>
+              </a:spcAft>
+              <a:buNone/>
+            </a:pPr>
+            <a:r>
+              <a:rPr lang="pt-PT" sz="1100" dirty="0">
+                <a:solidFill>
+                  <a:srgbClr val="5B6A7D"/>
+                </a:solidFill>
+                <a:latin typeface="Aptos" pitchFamily="34" charset="0"/>
+                <a:ea typeface="Aptos" pitchFamily="34" charset="-122"/>
+                <a:cs typeface="Aptos" pitchFamily="34" charset="-120"/>
+              </a:rPr>
+              <a:t>Publish/subscribe</a:t>
+            </a:r>
+          </a:p>
+        </p:txBody>
+      </p:sp>
+      <p:sp>
+        <p:nvSpPr>
+          <p:cNvPr id="108" name="Text 108"/>
+          <p:cNvSpPr txBox="1"/>
+          <p:nvPr/>
+        </p:nvSpPr>
+        <p:spPr>
+          <a:xfrm>
+            <a:off x="3383280" y="5394960"/>
+            <a:ext cx="2331720" cy="220000"/>
+          </a:xfrm>
+          <a:prstGeom prst="rect">
+            <a:avLst/>
+          </a:prstGeom>
+          <a:noFill/>
+          <a:ln>
+            <a:noFill/>
+          </a:ln>
+        </p:spPr>
+        <p:txBody>
+          <a:bodyPr wrap="square" lIns="0" tIns="0" rIns="0" bIns="0" rtlCol="0" anchor="t"/>
+          <a:lstStyle/>
+          <a:p>
+            <a:pPr algn="r" marL="0" indent="0">
+              <a:spcAft>
+                <a:spcPts val="0"/>
+              </a:spcAft>
+              <a:buNone/>
+            </a:pPr>
+            <a:r>
+              <a:rPr lang="pt-PT" sz="1100" b="1" dirty="0">
+                <a:solidFill>
+                  <a:srgbClr val="2463EB"/>
+                </a:solidFill>
+                <a:latin typeface="Aptos" pitchFamily="34" charset="0"/>
+                <a:ea typeface="Aptos" pitchFamily="34" charset="-122"/>
+                <a:cs typeface="Aptos" pitchFamily="34" charset="-120"/>
+              </a:rPr>
+              <a:t>SIS</a:t>
+            </a:r>
+          </a:p>
+        </p:txBody>
+      </p:sp>
+      <p:sp>
+        <p:nvSpPr>
+          <p:cNvPr id="109" name="Shape 109"/>
+          <p:cNvSpPr/>
+          <p:nvPr/>
+        </p:nvSpPr>
+        <p:spPr>
+          <a:xfrm>
+            <a:off x="6126480" y="1874520"/>
+            <a:ext cx="2468880" cy="3840480"/>
+          </a:xfrm>
+          <a:prstGeom prst="roundRect">
+            <a:avLst>
+              <a:gd name="adj" fmla="val 5000"/>
+            </a:avLst>
+          </a:prstGeom>
+          <a:noFill/>
+          <a:ln w="12700">
+            <a:solidFill>
+              <a:srgbClr val="5B6A7D"/>
+            </a:solidFill>
+            <a:prstDash val="dash"/>
+          </a:ln>
+        </p:spPr>
+      </p:sp>
+      <p:sp>
+        <p:nvSpPr>
+          <p:cNvPr id="110" name="Shape 110"/>
+          <p:cNvSpPr/>
+          <p:nvPr/>
+        </p:nvSpPr>
+        <p:spPr>
+          <a:xfrm>
+            <a:off x="6263640" y="2103120"/>
+            <a:ext cx="2194560" cy="1188720"/>
           </a:xfrm>
           <a:prstGeom prst="roundRect">
             <a:avLst>
@@ -3969,47 +4083,42 @@
           <a:solidFill>
             <a:srgbClr val="10243A"/>
           </a:solidFill>
-          <a:ln w="7620">
-            <a:solidFill>
-              <a:srgbClr val="10243A"/>
-            </a:solidFill>
-            <a:prstDash val="solid"/>
+          <a:ln>
+            <a:noFill/>
           </a:ln>
         </p:spPr>
-        <p:txBody>
-          <a:bodyPr/>
-          <a:lstStyle/>
-          <a:p>
-            <a:endParaRPr lang="pt-PT"/>
-          </a:p>
-        </p:txBody>
-      </p:sp>
-      <p:sp>
-        <p:nvSpPr>
-          <p:cNvPr id="15" name="Text 13"/>
-          <p:cNvSpPr/>
-          <p:nvPr/>
-        </p:nvSpPr>
-        <p:spPr>
-          <a:xfrm>
-            <a:off x="8677656" y="1929384"/>
-            <a:ext cx="3264408" cy="365760"/>
-          </a:xfrm>
-          <a:prstGeom prst="rect">
-            <a:avLst/>
-          </a:prstGeom>
-          <a:noFill/>
-          <a:ln/>
-        </p:spPr>
-        <p:txBody>
-          <a:bodyPr wrap="square" lIns="0" tIns="0" rIns="0" bIns="0" rtlCol="0" anchor="ctr"/>
-          <a:lstStyle/>
-          <a:p>
-            <a:pPr marL="0" indent="0" algn="ctr">
-              <a:buNone/>
-            </a:pPr>
-            <a:r>
-              <a:rPr lang="en-US" sz="1900" b="1" dirty="0">
+      </p:sp>
+      <p:sp>
+        <p:nvSpPr>
+          <p:cNvPr id="111" name="Text 111"/>
+          <p:cNvSpPr txBox="1"/>
+          <p:nvPr/>
+        </p:nvSpPr>
+        <p:spPr>
+          <a:xfrm>
+            <a:off x="6353640" y="2273120"/>
+            <a:ext cx="2014560" cy="848720"/>
+          </a:xfrm>
+          <a:prstGeom prst="rect">
+            <a:avLst/>
+          </a:prstGeom>
+          <a:noFill/>
+          <a:ln>
+            <a:noFill/>
+          </a:ln>
+        </p:spPr>
+        <p:txBody>
+          <a:bodyPr wrap="square" lIns="0" tIns="0" rIns="0" bIns="0" rtlCol="0" anchor="ctr"/>
+          <a:lstStyle/>
+          <a:p>
+            <a:pPr algn="ctr" marL="0" indent="0">
+              <a:spcAft>
+                <a:spcPts val="300"/>
+              </a:spcAft>
+              <a:buNone/>
+            </a:pPr>
+            <a:r>
+              <a:rPr lang="pt-PT" sz="1700" b="1" dirty="0">
                 <a:solidFill>
                   <a:srgbClr val="FFFFFF"/>
                 </a:solidFill>
@@ -4017,139 +4126,283 @@
                 <a:ea typeface="Aptos" pitchFamily="34" charset="-122"/>
                 <a:cs typeface="Aptos" pitchFamily="34" charset="-120"/>
               </a:rPr>
-              <a:t>App Android</a:t>
-            </a:r>
-            <a:endParaRPr lang="en-US" sz="1900" dirty="0"/>
-          </a:p>
-        </p:txBody>
-      </p:sp>
-      <p:sp>
-        <p:nvSpPr>
-          <p:cNvPr id="16" name="Text 14"/>
-          <p:cNvSpPr/>
-          <p:nvPr/>
-        </p:nvSpPr>
-        <p:spPr>
-          <a:xfrm>
-            <a:off x="8677656" y="2404872"/>
-            <a:ext cx="3264408" cy="292608"/>
-          </a:xfrm>
-          <a:prstGeom prst="rect">
-            <a:avLst/>
-          </a:prstGeom>
-          <a:noFill/>
-          <a:ln/>
-        </p:spPr>
-        <p:txBody>
-          <a:bodyPr wrap="square" lIns="0" tIns="0" rIns="0" bIns="0" rtlCol="0" anchor="ctr"/>
-          <a:lstStyle/>
-          <a:p>
-            <a:pPr marL="0" indent="0" algn="ctr">
-              <a:buNone/>
-            </a:pPr>
-            <a:r>
-              <a:rPr lang="en-US" sz="1200" dirty="0">
-                <a:solidFill>
-                  <a:srgbClr val="D9E8FA"/>
-                </a:solidFill>
-                <a:latin typeface="Aptos" pitchFamily="34" charset="0"/>
-                <a:ea typeface="Aptos" pitchFamily="34" charset="-122"/>
-                <a:cs typeface="Aptos" pitchFamily="34" charset="-120"/>
-              </a:rPr>
-              <a:t>Colaborador e coordenador</a:t>
-            </a:r>
-            <a:endParaRPr lang="en-US" sz="1200" dirty="0"/>
-          </a:p>
-        </p:txBody>
-      </p:sp>
-      <p:sp>
-        <p:nvSpPr>
-          <p:cNvPr id="17" name="Shape 15"/>
-          <p:cNvSpPr/>
-          <p:nvPr/>
-        </p:nvSpPr>
-        <p:spPr>
-          <a:xfrm>
-            <a:off x="4242816" y="3995928"/>
-            <a:ext cx="3712464" cy="1033272"/>
+              <a:t>Front-office</a:t>
+            </a:r>
+          </a:p>
+          <a:p>
+            <a:pPr algn="ctr" marL="0" indent="0">
+              <a:spcAft>
+                <a:spcPts val="0"/>
+              </a:spcAft>
+              <a:buNone/>
+            </a:pPr>
+            <a:r>
+              <a:rPr lang="pt-PT" sz="1100" dirty="0">
+                <a:solidFill>
+                  <a:srgbClr val="DCE6F5"/>
+                </a:solidFill>
+                <a:latin typeface="Aptos" pitchFamily="34" charset="0"/>
+                <a:ea typeface="Aptos" pitchFamily="34" charset="-122"/>
+                <a:cs typeface="Aptos" pitchFamily="34" charset="-120"/>
+              </a:rPr>
+              <a:t>Colaborador</a:t>
+            </a:r>
+          </a:p>
+        </p:txBody>
+      </p:sp>
+      <p:sp>
+        <p:nvSpPr>
+          <p:cNvPr id="112" name="Shape 112"/>
+          <p:cNvSpPr/>
+          <p:nvPr/>
+        </p:nvSpPr>
+        <p:spPr>
+          <a:xfrm>
+            <a:off x="6263640" y="3794760"/>
+            <a:ext cx="2194560" cy="1188720"/>
           </a:xfrm>
           <a:prstGeom prst="roundRect">
             <a:avLst>
-              <a:gd name="adj" fmla="val 12389"/>
+              <a:gd name="adj" fmla="val 8784"/>
             </a:avLst>
           </a:prstGeom>
           <a:solidFill>
-            <a:srgbClr val="11A89B"/>
-          </a:solidFill>
-          <a:ln w="7620">
+            <a:srgbClr val="10243A"/>
+          </a:solidFill>
+          <a:ln>
+            <a:noFill/>
+          </a:ln>
+        </p:spPr>
+      </p:sp>
+      <p:sp>
+        <p:nvSpPr>
+          <p:cNvPr id="113" name="Text 113"/>
+          <p:cNvSpPr txBox="1"/>
+          <p:nvPr/>
+        </p:nvSpPr>
+        <p:spPr>
+          <a:xfrm>
+            <a:off x="6353640" y="3964760"/>
+            <a:ext cx="2014560" cy="848720"/>
+          </a:xfrm>
+          <a:prstGeom prst="rect">
+            <a:avLst/>
+          </a:prstGeom>
+          <a:noFill/>
+          <a:ln>
+            <a:noFill/>
+          </a:ln>
+        </p:spPr>
+        <p:txBody>
+          <a:bodyPr wrap="square" lIns="0" tIns="0" rIns="0" bIns="0" rtlCol="0" anchor="ctr"/>
+          <a:lstStyle/>
+          <a:p>
+            <a:pPr algn="ctr" marL="0" indent="0">
+              <a:spcAft>
+                <a:spcPts val="300"/>
+              </a:spcAft>
+              <a:buNone/>
+            </a:pPr>
+            <a:r>
+              <a:rPr lang="pt-PT" sz="1700" b="1" dirty="0">
+                <a:solidFill>
+                  <a:srgbClr val="FFFFFF"/>
+                </a:solidFill>
+                <a:latin typeface="Aptos" pitchFamily="34" charset="0"/>
+                <a:ea typeface="Aptos" pitchFamily="34" charset="-122"/>
+                <a:cs typeface="Aptos" pitchFamily="34" charset="-120"/>
+              </a:rPr>
+              <a:t>Back-office</a:t>
+            </a:r>
+          </a:p>
+          <a:p>
+            <a:pPr algn="ctr" marL="0" indent="0">
+              <a:spcAft>
+                <a:spcPts val="0"/>
+              </a:spcAft>
+              <a:buNone/>
+            </a:pPr>
+            <a:r>
+              <a:rPr lang="pt-PT" sz="1100" dirty="0">
+                <a:solidFill>
+                  <a:srgbClr val="DCE6F5"/>
+                </a:solidFill>
+                <a:latin typeface="Aptos" pitchFamily="34" charset="0"/>
+                <a:ea typeface="Aptos" pitchFamily="34" charset="-122"/>
+                <a:cs typeface="Aptos" pitchFamily="34" charset="-120"/>
+              </a:rPr>
+              <a:t>Coordenador, técnico e admin</a:t>
+            </a:r>
+          </a:p>
+        </p:txBody>
+      </p:sp>
+      <p:sp>
+        <p:nvSpPr>
+          <p:cNvPr id="114" name="Text 114"/>
+          <p:cNvSpPr txBox="1"/>
+          <p:nvPr/>
+        </p:nvSpPr>
+        <p:spPr>
+          <a:xfrm>
+            <a:off x="6126480" y="5394960"/>
+            <a:ext cx="2331720" cy="220000"/>
+          </a:xfrm>
+          <a:prstGeom prst="rect">
+            <a:avLst/>
+          </a:prstGeom>
+          <a:noFill/>
+          <a:ln>
+            <a:noFill/>
+          </a:ln>
+        </p:spPr>
+        <p:txBody>
+          <a:bodyPr wrap="square" lIns="0" tIns="0" rIns="0" bIns="0" rtlCol="0" anchor="t"/>
+          <a:lstStyle/>
+          <a:p>
+            <a:pPr algn="r" marL="0" indent="0">
+              <a:spcAft>
+                <a:spcPts val="0"/>
+              </a:spcAft>
+              <a:buNone/>
+            </a:pPr>
+            <a:r>
+              <a:rPr lang="pt-PT" sz="1100" b="1" dirty="0">
+                <a:solidFill>
+                  <a:srgbClr val="2463EB"/>
+                </a:solidFill>
+                <a:latin typeface="Aptos" pitchFamily="34" charset="0"/>
+                <a:ea typeface="Aptos" pitchFamily="34" charset="-122"/>
+                <a:cs typeface="Aptos" pitchFamily="34" charset="-120"/>
+              </a:rPr>
+              <a:t>PLSI</a:t>
+            </a:r>
+          </a:p>
+        </p:txBody>
+      </p:sp>
+      <p:sp>
+        <p:nvSpPr>
+          <p:cNvPr id="115" name="Text 115"/>
+          <p:cNvSpPr txBox="1"/>
+          <p:nvPr/>
+        </p:nvSpPr>
+        <p:spPr>
+          <a:xfrm>
+            <a:off x="3383280" y="5806440"/>
+            <a:ext cx="5212080" cy="365760"/>
+          </a:xfrm>
+          <a:prstGeom prst="rect">
+            <a:avLst/>
+          </a:prstGeom>
+          <a:noFill/>
+          <a:ln>
+            <a:noFill/>
+          </a:ln>
+        </p:spPr>
+        <p:txBody>
+          <a:bodyPr wrap="square" lIns="0" tIns="0" rIns="0" bIns="0" rtlCol="0" anchor="ctr"/>
+          <a:lstStyle/>
+          <a:p>
+            <a:pPr algn="ctr" marL="0" indent="0">
+              <a:spcAft>
+                <a:spcPts val="0"/>
+              </a:spcAft>
+              <a:buNone/>
+            </a:pPr>
+            <a:r>
+              <a:rPr lang="pt-PT" sz="1100" i="1" dirty="0">
+                <a:solidFill>
+                  <a:srgbClr val="5B6A7D"/>
+                </a:solidFill>
+                <a:latin typeface="Aptos" pitchFamily="34" charset="0"/>
+                <a:ea typeface="Aptos" pitchFamily="34" charset="-122"/>
+                <a:cs typeface="Aptos" pitchFamily="34" charset="-120"/>
+              </a:rPr>
+              <a:t>Web e API partilham os mesmos modelos (common/models)</a:t>
+            </a:r>
+          </a:p>
+        </p:txBody>
+      </p:sp>
+      <p:cxnSp>
+        <p:nvCxnSpPr>
+          <p:cNvPr id="116" name="Connector 116"/>
+          <p:cNvCxnSpPr/>
+          <p:nvPr/>
+        </p:nvCxnSpPr>
+        <p:spPr>
+          <a:xfrm>
+            <a:off x="5715000" y="4389120"/>
+            <a:ext cx="548640" cy="0"/>
+          </a:xfrm>
+          <a:prstGeom prst="straightConnector1">
+            <a:avLst/>
+          </a:prstGeom>
+          <a:ln w="29210">
             <a:solidFill>
               <a:srgbClr val="11A89B"/>
             </a:solidFill>
             <a:prstDash val="solid"/>
+            <a:headEnd type="triangle"/>
+            <a:tailEnd type="none"/>
           </a:ln>
         </p:spPr>
-        <p:txBody>
-          <a:bodyPr/>
-          <a:lstStyle/>
-          <a:p>
-            <a:endParaRPr lang="pt-PT"/>
-          </a:p>
-        </p:txBody>
-      </p:sp>
-      <p:sp>
-        <p:nvSpPr>
-          <p:cNvPr id="18" name="Text 16"/>
-          <p:cNvSpPr/>
-          <p:nvPr/>
-        </p:nvSpPr>
-        <p:spPr>
-          <a:xfrm>
-            <a:off x="4434840" y="4270248"/>
-            <a:ext cx="3337560" cy="393192"/>
-          </a:xfrm>
-          <a:prstGeom prst="rect">
-            <a:avLst/>
-          </a:prstGeom>
-          <a:noFill/>
-          <a:ln/>
-        </p:spPr>
-        <p:txBody>
-          <a:bodyPr wrap="square" lIns="0" tIns="0" rIns="0" bIns="0" rtlCol="0" anchor="ctr"/>
-          <a:lstStyle/>
-          <a:p>
-            <a:pPr marL="0" indent="0" algn="ctr">
-              <a:buNone/>
-            </a:pPr>
-            <a:r>
-              <a:rPr lang="en-US" sz="2100" b="1" dirty="0">
-                <a:solidFill>
-                  <a:srgbClr val="FFFFFF"/>
-                </a:solidFill>
-                <a:latin typeface="Aptos" pitchFamily="34" charset="0"/>
-                <a:ea typeface="Aptos" pitchFamily="34" charset="-122"/>
-                <a:cs typeface="Aptos" pitchFamily="34" charset="-120"/>
-              </a:rPr>
-              <a:t>Base de dados MySQL</a:t>
-            </a:r>
-            <a:endParaRPr lang="en-US" sz="2100" dirty="0"/>
-          </a:p>
-        </p:txBody>
-      </p:sp>
-      <p:sp>
-        <p:nvSpPr>
-          <p:cNvPr id="19" name="Shape 17"/>
-          <p:cNvSpPr/>
-          <p:nvPr/>
-        </p:nvSpPr>
-        <p:spPr>
-          <a:xfrm>
-            <a:off x="2286000" y="3044952"/>
-            <a:ext cx="3803904" cy="941832"/>
-          </a:xfrm>
-          <a:prstGeom prst="line">
-            <a:avLst/>
-          </a:prstGeom>
-          <a:noFill/>
+      </p:cxnSp>
+      <p:sp>
+        <p:nvSpPr>
+          <p:cNvPr id="117" name="Text 117"/>
+          <p:cNvSpPr txBox="1"/>
+          <p:nvPr/>
+        </p:nvSpPr>
+        <p:spPr>
+          <a:xfrm>
+            <a:off x="5715000" y="4089120"/>
+            <a:ext cx="548640" cy="230000"/>
+          </a:xfrm>
+          <a:prstGeom prst="rect">
+            <a:avLst/>
+          </a:prstGeom>
+          <a:noFill/>
+          <a:ln>
+            <a:noFill/>
+          </a:ln>
+        </p:spPr>
+        <p:txBody>
+          <a:bodyPr wrap="square" lIns="0" tIns="0" rIns="0" bIns="0" rtlCol="0" anchor="ctr"/>
+          <a:lstStyle/>
+          <a:p>
+            <a:pPr algn="ctr" marL="0" indent="0">
+              <a:spcAft>
+                <a:spcPts val="0"/>
+              </a:spcAft>
+              <a:buNone/>
+            </a:pPr>
+            <a:r>
+              <a:rPr lang="pt-PT" sz="1000" b="1" dirty="0">
+                <a:solidFill>
+                  <a:srgbClr val="5B6A7D"/>
+                </a:solidFill>
+                <a:latin typeface="Aptos" pitchFamily="34" charset="0"/>
+                <a:ea typeface="Aptos" pitchFamily="34" charset="-122"/>
+                <a:cs typeface="Aptos" pitchFamily="34" charset="-120"/>
+              </a:rPr>
+              <a:t>publica</a:t>
+            </a:r>
+          </a:p>
+        </p:txBody>
+      </p:sp>
+      <p:cxnSp>
+        <p:nvCxnSpPr>
+          <p:cNvPr id="118" name="Connector 118"/>
+          <p:cNvCxnSpPr/>
+          <p:nvPr/>
+        </p:nvCxnSpPr>
+        <p:spPr>
+          <a:xfrm>
+            <a:off x="4617720" y="3291840"/>
+            <a:ext cx="0" cy="502920"/>
+          </a:xfrm>
+          <a:prstGeom prst="straightConnector1">
+            <a:avLst/>
+          </a:prstGeom>
           <a:ln w="29210">
             <a:solidFill>
               <a:srgbClr val="11A89B"/>
@@ -4159,117 +4412,423 @@
             <a:tailEnd type="triangle"/>
           </a:ln>
         </p:spPr>
-        <p:txBody>
-          <a:bodyPr/>
-          <a:lstStyle/>
-          <a:p>
-            <a:endParaRPr lang="pt-PT"/>
-          </a:p>
-        </p:txBody>
-      </p:sp>
-      <p:sp>
-        <p:nvSpPr>
-          <p:cNvPr id="20" name="Shape 18"/>
-          <p:cNvSpPr/>
-          <p:nvPr/>
-        </p:nvSpPr>
-        <p:spPr>
-          <a:xfrm flipH="1">
-            <a:off x="6089904" y="3044952"/>
-            <a:ext cx="36576" cy="941832"/>
-          </a:xfrm>
-          <a:prstGeom prst="line">
-            <a:avLst/>
-          </a:prstGeom>
-          <a:noFill/>
+      </p:cxnSp>
+      <p:sp>
+        <p:nvSpPr>
+          <p:cNvPr id="119" name="Text 119"/>
+          <p:cNvSpPr txBox="1"/>
+          <p:nvPr/>
+        </p:nvSpPr>
+        <p:spPr>
+          <a:xfrm>
+            <a:off x="4709160" y="3429000"/>
+            <a:ext cx="1000000" cy="230000"/>
+          </a:xfrm>
+          <a:prstGeom prst="rect">
+            <a:avLst/>
+          </a:prstGeom>
+          <a:noFill/>
+          <a:ln>
+            <a:noFill/>
+          </a:ln>
+        </p:spPr>
+        <p:txBody>
+          <a:bodyPr wrap="square" lIns="0" tIns="0" rIns="0" bIns="0" rtlCol="0" anchor="ctr"/>
+          <a:lstStyle/>
+          <a:p>
+            <a:pPr algn="l" marL="0" indent="0">
+              <a:spcAft>
+                <a:spcPts val="0"/>
+              </a:spcAft>
+              <a:buNone/>
+            </a:pPr>
+            <a:r>
+              <a:rPr lang="pt-PT" sz="1000" b="1" dirty="0">
+                <a:solidFill>
+                  <a:srgbClr val="5B6A7D"/>
+                </a:solidFill>
+                <a:latin typeface="Aptos" pitchFamily="34" charset="0"/>
+                <a:ea typeface="Aptos" pitchFamily="34" charset="-122"/>
+                <a:cs typeface="Aptos" pitchFamily="34" charset="-120"/>
+              </a:rPr>
+              <a:t>publica</a:t>
+            </a:r>
+          </a:p>
+        </p:txBody>
+      </p:sp>
+      <p:sp>
+        <p:nvSpPr>
+          <p:cNvPr id="120" name="Shape 120"/>
+          <p:cNvSpPr/>
+          <p:nvPr/>
+        </p:nvSpPr>
+        <p:spPr>
+          <a:xfrm>
+            <a:off x="566928" y="2103120"/>
+            <a:ext cx="2148840" cy="2880360"/>
+          </a:xfrm>
+          <a:prstGeom prst="roundRect">
+            <a:avLst>
+              <a:gd name="adj" fmla="val 8784"/>
+            </a:avLst>
+          </a:prstGeom>
+          <a:solidFill>
+            <a:srgbClr val="10243A"/>
+          </a:solidFill>
+          <a:ln>
+            <a:noFill/>
+          </a:ln>
+        </p:spPr>
+      </p:sp>
+      <p:sp>
+        <p:nvSpPr>
+          <p:cNvPr id="121" name="Text 121"/>
+          <p:cNvSpPr txBox="1"/>
+          <p:nvPr/>
+        </p:nvSpPr>
+        <p:spPr>
+          <a:xfrm>
+            <a:off x="656928" y="2273120"/>
+            <a:ext cx="1968840" cy="2540360"/>
+          </a:xfrm>
+          <a:prstGeom prst="rect">
+            <a:avLst/>
+          </a:prstGeom>
+          <a:noFill/>
+          <a:ln>
+            <a:noFill/>
+          </a:ln>
+        </p:spPr>
+        <p:txBody>
+          <a:bodyPr wrap="square" lIns="0" tIns="0" rIns="0" bIns="0" rtlCol="0" anchor="ctr"/>
+          <a:lstStyle/>
+          <a:p>
+            <a:pPr algn="ctr" marL="0" indent="0">
+              <a:spcAft>
+                <a:spcPts val="300"/>
+              </a:spcAft>
+              <a:buNone/>
+            </a:pPr>
+            <a:r>
+              <a:rPr lang="pt-PT" sz="1700" b="1" dirty="0">
+                <a:solidFill>
+                  <a:srgbClr val="FFFFFF"/>
+                </a:solidFill>
+                <a:latin typeface="Aptos" pitchFamily="34" charset="0"/>
+                <a:ea typeface="Aptos" pitchFamily="34" charset="-122"/>
+                <a:cs typeface="Aptos" pitchFamily="34" charset="-120"/>
+              </a:rPr>
+              <a:t>App Android</a:t>
+            </a:r>
+          </a:p>
+          <a:p>
+            <a:pPr algn="ctr" marL="0" indent="0">
+              <a:spcAft>
+                <a:spcPts val="0"/>
+              </a:spcAft>
+              <a:buNone/>
+            </a:pPr>
+            <a:r>
+              <a:rPr lang="pt-PT" sz="1100" dirty="0">
+                <a:solidFill>
+                  <a:srgbClr val="DCE6F5"/>
+                </a:solidFill>
+                <a:latin typeface="Aptos" pitchFamily="34" charset="0"/>
+                <a:ea typeface="Aptos" pitchFamily="34" charset="-122"/>
+                <a:cs typeface="Aptos" pitchFamily="34" charset="-120"/>
+              </a:rPr>
+              <a:t>Colaborador e coordenador</a:t>
+            </a:r>
+          </a:p>
+        </p:txBody>
+      </p:sp>
+      <p:sp>
+        <p:nvSpPr>
+          <p:cNvPr id="122" name="Text 122"/>
+          <p:cNvSpPr txBox="1"/>
+          <p:nvPr/>
+        </p:nvSpPr>
+        <p:spPr>
+          <a:xfrm>
+            <a:off x="566928" y="5074920"/>
+            <a:ext cx="2148840" cy="220000"/>
+          </a:xfrm>
+          <a:prstGeom prst="rect">
+            <a:avLst/>
+          </a:prstGeom>
+          <a:noFill/>
+          <a:ln>
+            <a:noFill/>
+          </a:ln>
+        </p:spPr>
+        <p:txBody>
+          <a:bodyPr wrap="square" lIns="0" tIns="0" rIns="0" bIns="0" rtlCol="0" anchor="t"/>
+          <a:lstStyle/>
+          <a:p>
+            <a:pPr algn="r" marL="0" indent="0">
+              <a:spcAft>
+                <a:spcPts val="0"/>
+              </a:spcAft>
+              <a:buNone/>
+            </a:pPr>
+            <a:r>
+              <a:rPr lang="pt-PT" sz="1100" b="1" dirty="0">
+                <a:solidFill>
+                  <a:srgbClr val="2463EB"/>
+                </a:solidFill>
+                <a:latin typeface="Aptos" pitchFamily="34" charset="0"/>
+                <a:ea typeface="Aptos" pitchFamily="34" charset="-122"/>
+                <a:cs typeface="Aptos" pitchFamily="34" charset="-120"/>
+              </a:rPr>
+              <a:t>AMSI</a:t>
+            </a:r>
+          </a:p>
+        </p:txBody>
+      </p:sp>
+      <p:cxnSp>
+        <p:nvCxnSpPr>
+          <p:cNvPr id="123" name="Connector 123"/>
+          <p:cNvCxnSpPr/>
+          <p:nvPr/>
+        </p:nvCxnSpPr>
+        <p:spPr>
+          <a:xfrm>
+            <a:off x="2715768" y="2697480"/>
+            <a:ext cx="804672" cy="0"/>
+          </a:xfrm>
+          <a:prstGeom prst="straightConnector1">
+            <a:avLst/>
+          </a:prstGeom>
           <a:ln w="29210">
             <a:solidFill>
               <a:srgbClr val="11A89B"/>
             </a:solidFill>
             <a:prstDash val="solid"/>
-            <a:headEnd type="none"/>
+            <a:headEnd type="triangle"/>
             <a:tailEnd type="triangle"/>
           </a:ln>
         </p:spPr>
-        <p:txBody>
-          <a:bodyPr/>
-          <a:lstStyle/>
-          <a:p>
-            <a:endParaRPr lang="pt-PT"/>
-          </a:p>
-        </p:txBody>
-      </p:sp>
-      <p:sp>
-        <p:nvSpPr>
-          <p:cNvPr id="21" name="Shape 19"/>
-          <p:cNvSpPr/>
-          <p:nvPr/>
-        </p:nvSpPr>
-        <p:spPr>
-          <a:xfrm flipH="1">
-            <a:off x="6089904" y="3044952"/>
-            <a:ext cx="3922776" cy="941832"/>
-          </a:xfrm>
-          <a:prstGeom prst="line">
-            <a:avLst/>
-          </a:prstGeom>
-          <a:noFill/>
+      </p:cxnSp>
+      <p:sp>
+        <p:nvSpPr>
+          <p:cNvPr id="124" name="Text 124"/>
+          <p:cNvSpPr txBox="1"/>
+          <p:nvPr/>
+        </p:nvSpPr>
+        <p:spPr>
+          <a:xfrm>
+            <a:off x="2715768" y="2397480"/>
+            <a:ext cx="804672" cy="230000"/>
+          </a:xfrm>
+          <a:prstGeom prst="rect">
+            <a:avLst/>
+          </a:prstGeom>
+          <a:noFill/>
+          <a:ln>
+            <a:noFill/>
+          </a:ln>
+        </p:spPr>
+        <p:txBody>
+          <a:bodyPr wrap="square" lIns="0" tIns="0" rIns="0" bIns="0" rtlCol="0" anchor="ctr"/>
+          <a:lstStyle/>
+          <a:p>
+            <a:pPr algn="ctr" marL="0" indent="0">
+              <a:spcAft>
+                <a:spcPts val="0"/>
+              </a:spcAft>
+              <a:buNone/>
+            </a:pPr>
+            <a:r>
+              <a:rPr lang="pt-PT" sz="1000" b="1" dirty="0">
+                <a:solidFill>
+                  <a:srgbClr val="5B6A7D"/>
+                </a:solidFill>
+                <a:latin typeface="Aptos" pitchFamily="34" charset="0"/>
+                <a:ea typeface="Aptos" pitchFamily="34" charset="-122"/>
+                <a:cs typeface="Aptos" pitchFamily="34" charset="-120"/>
+              </a:rPr>
+              <a:t>HTTP</a:t>
+            </a:r>
+          </a:p>
+        </p:txBody>
+      </p:sp>
+      <p:cxnSp>
+        <p:nvCxnSpPr>
+          <p:cNvPr id="125" name="Connector 125"/>
+          <p:cNvCxnSpPr/>
+          <p:nvPr/>
+        </p:nvCxnSpPr>
+        <p:spPr>
+          <a:xfrm>
+            <a:off x="2715768" y="4389120"/>
+            <a:ext cx="804672" cy="0"/>
+          </a:xfrm>
+          <a:prstGeom prst="straightConnector1">
+            <a:avLst/>
+          </a:prstGeom>
           <a:ln w="29210">
             <a:solidFill>
               <a:srgbClr val="11A89B"/>
             </a:solidFill>
             <a:prstDash val="solid"/>
-            <a:headEnd type="none"/>
+            <a:headEnd type="triangle"/>
+            <a:tailEnd type="none"/>
+          </a:ln>
+        </p:spPr>
+      </p:cxnSp>
+      <p:sp>
+        <p:nvSpPr>
+          <p:cNvPr id="126" name="Text 126"/>
+          <p:cNvSpPr txBox="1"/>
+          <p:nvPr/>
+        </p:nvSpPr>
+        <p:spPr>
+          <a:xfrm>
+            <a:off x="2715768" y="4089120"/>
+            <a:ext cx="804672" cy="230000"/>
+          </a:xfrm>
+          <a:prstGeom prst="rect">
+            <a:avLst/>
+          </a:prstGeom>
+          <a:noFill/>
+          <a:ln>
+            <a:noFill/>
+          </a:ln>
+        </p:spPr>
+        <p:txBody>
+          <a:bodyPr wrap="square" lIns="0" tIns="0" rIns="0" bIns="0" rtlCol="0" anchor="ctr"/>
+          <a:lstStyle/>
+          <a:p>
+            <a:pPr algn="ctr" marL="0" indent="0">
+              <a:spcAft>
+                <a:spcPts val="0"/>
+              </a:spcAft>
+              <a:buNone/>
+            </a:pPr>
+            <a:r>
+              <a:rPr lang="pt-PT" sz="1000" b="1" dirty="0">
+                <a:solidFill>
+                  <a:srgbClr val="5B6A7D"/>
+                </a:solidFill>
+                <a:latin typeface="Aptos" pitchFamily="34" charset="0"/>
+                <a:ea typeface="Aptos" pitchFamily="34" charset="-122"/>
+                <a:cs typeface="Aptos" pitchFamily="34" charset="-120"/>
+              </a:rPr>
+              <a:t>subscreve</a:t>
+            </a:r>
+          </a:p>
+        </p:txBody>
+      </p:sp>
+      <p:sp>
+        <p:nvSpPr>
+          <p:cNvPr id="127" name="Shape 127"/>
+          <p:cNvSpPr/>
+          <p:nvPr/>
+        </p:nvSpPr>
+        <p:spPr>
+          <a:xfrm>
+            <a:off x="9235440" y="3314700"/>
+            <a:ext cx="2395728" cy="1051560"/>
+          </a:xfrm>
+          <a:prstGeom prst="roundRect">
+            <a:avLst>
+              <a:gd name="adj" fmla="val 8784"/>
+            </a:avLst>
+          </a:prstGeom>
+          <a:solidFill>
+            <a:srgbClr val="11A89B"/>
+          </a:solidFill>
+          <a:ln>
+            <a:noFill/>
+          </a:ln>
+        </p:spPr>
+      </p:sp>
+      <p:sp>
+        <p:nvSpPr>
+          <p:cNvPr id="128" name="Text 128"/>
+          <p:cNvSpPr txBox="1"/>
+          <p:nvPr/>
+        </p:nvSpPr>
+        <p:spPr>
+          <a:xfrm>
+            <a:off x="9325440" y="3484700"/>
+            <a:ext cx="2215728" cy="711560"/>
+          </a:xfrm>
+          <a:prstGeom prst="rect">
+            <a:avLst/>
+          </a:prstGeom>
+          <a:noFill/>
+          <a:ln>
+            <a:noFill/>
+          </a:ln>
+        </p:spPr>
+        <p:txBody>
+          <a:bodyPr wrap="square" lIns="0" tIns="0" rIns="0" bIns="0" rtlCol="0" anchor="ctr"/>
+          <a:lstStyle/>
+          <a:p>
+            <a:pPr algn="ctr" marL="0" indent="0">
+              <a:spcAft>
+                <a:spcPts val="300"/>
+              </a:spcAft>
+              <a:buNone/>
+            </a:pPr>
+            <a:r>
+              <a:rPr lang="pt-PT" sz="1700" b="1" dirty="0">
+                <a:solidFill>
+                  <a:srgbClr val="FFFFFF"/>
+                </a:solidFill>
+                <a:latin typeface="Aptos" pitchFamily="34" charset="0"/>
+                <a:ea typeface="Aptos" pitchFamily="34" charset="-122"/>
+                <a:cs typeface="Aptos" pitchFamily="34" charset="-120"/>
+              </a:rPr>
+              <a:t>Base de dados</a:t>
+            </a:r>
+          </a:p>
+          <a:p>
+            <a:pPr algn="ctr" marL="0" indent="0">
+              <a:spcAft>
+                <a:spcPts val="0"/>
+              </a:spcAft>
+              <a:buNone/>
+            </a:pPr>
+            <a:r>
+              <a:rPr lang="pt-PT" sz="1100" dirty="0">
+                <a:solidFill>
+                  <a:srgbClr val="E3F7F4"/>
+                </a:solidFill>
+                <a:latin typeface="Aptos" pitchFamily="34" charset="0"/>
+                <a:ea typeface="Aptos" pitchFamily="34" charset="-122"/>
+                <a:cs typeface="Aptos" pitchFamily="34" charset="-120"/>
+              </a:rPr>
+              <a:t>MySQL (única)</a:t>
+            </a:r>
+          </a:p>
+        </p:txBody>
+      </p:sp>
+      <p:cxnSp>
+        <p:nvCxnSpPr>
+          <p:cNvPr id="129" name="Connector 129"/>
+          <p:cNvCxnSpPr/>
+          <p:nvPr/>
+        </p:nvCxnSpPr>
+        <p:spPr>
+          <a:xfrm>
+            <a:off x="8778240" y="3840480"/>
+            <a:ext cx="457200" cy="0"/>
+          </a:xfrm>
+          <a:prstGeom prst="straightConnector1">
+            <a:avLst/>
+          </a:prstGeom>
+          <a:ln w="29210">
+            <a:solidFill>
+              <a:srgbClr val="11A89B"/>
+            </a:solidFill>
+            <a:prstDash val="solid"/>
+            <a:headEnd type="triangle"/>
             <a:tailEnd type="triangle"/>
           </a:ln>
         </p:spPr>
-        <p:txBody>
-          <a:bodyPr/>
-          <a:lstStyle/>
-          <a:p>
-            <a:endParaRPr lang="pt-PT"/>
-          </a:p>
-        </p:txBody>
-      </p:sp>
-      <p:sp>
-        <p:nvSpPr>
-          <p:cNvPr id="22" name="Text 20"/>
-          <p:cNvSpPr/>
-          <p:nvPr/>
-        </p:nvSpPr>
-        <p:spPr>
-          <a:xfrm>
-            <a:off x="1133856" y="5660136"/>
-            <a:ext cx="9966960" cy="365760"/>
-          </a:xfrm>
-          <a:prstGeom prst="rect">
-            <a:avLst/>
-          </a:prstGeom>
-          <a:noFill/>
-          <a:ln/>
-        </p:spPr>
-        <p:txBody>
-          <a:bodyPr wrap="square" lIns="0" tIns="0" rIns="0" bIns="0" rtlCol="0" anchor="ctr"/>
-          <a:lstStyle/>
-          <a:p>
-            <a:pPr marL="0" indent="0" algn="ctr">
-              <a:buNone/>
-            </a:pPr>
-            <a:r>
-              <a:rPr lang="en-US" sz="1600" dirty="0">
-                <a:solidFill>
-                  <a:srgbClr val="5B6A7D"/>
-                </a:solidFill>
-                <a:latin typeface="Aptos" pitchFamily="34" charset="0"/>
-                <a:ea typeface="Aptos" pitchFamily="34" charset="-122"/>
-                <a:cs typeface="Aptos" pitchFamily="34" charset="-120"/>
-              </a:rPr>
-              <a:t>Notificações em tempo real por messaging (publish/subscribe)</a:t>
-            </a:r>
-            <a:endParaRPr lang="en-US" sz="1600" dirty="0"/>
-          </a:p>
-        </p:txBody>
-      </p:sp>
+      </p:cxnSp>
     </p:spTree>
   </p:cSld>
   <p:clrMapOvr>

</xml_diff>